<commit_message>
make minor update to base for slides
</commit_message>
<xml_diff>
--- a/assets/ppt/slide_base.pptx
+++ b/assets/ppt/slide_base.pptx
@@ -9,6 +9,7 @@
     <p:sldId id="257" r:id="rId3"/>
     <p:sldId id="258" r:id="rId4"/>
     <p:sldId id="259" r:id="rId5"/>
+    <p:sldId id="260" r:id="rId6"/>
   </p:sldIdLst>
   <p:sldSz cx="12192000" cy="6858000"/>
   <p:notesSz cx="6858000" cy="9144000"/>
@@ -14126,6 +14127,3074 @@
     <p:extLst>
       <p:ext uri="{BB962C8B-B14F-4D97-AF65-F5344CB8AC3E}">
         <p14:creationId xmlns:p14="http://schemas.microsoft.com/office/powerpoint/2010/main" val="228501646"/>
+      </p:ext>
+    </p:extLst>
+  </p:cSld>
+  <p:clrMapOvr>
+    <a:masterClrMapping/>
+  </p:clrMapOvr>
+</p:sld>
+</file>
+
+<file path=ppt/slides/slide5.xml><?xml version="1.0" encoding="utf-8"?>
+<p:sld xmlns:a="http://schemas.openxmlformats.org/drawingml/2006/main" xmlns:r="http://schemas.openxmlformats.org/officeDocument/2006/relationships" xmlns:p="http://schemas.openxmlformats.org/presentationml/2006/main">
+  <p:cSld>
+    <p:spTree>
+      <p:nvGrpSpPr>
+        <p:cNvPr id="1" name="">
+          <a:extLst>
+            <a:ext uri="{FF2B5EF4-FFF2-40B4-BE49-F238E27FC236}">
+              <a16:creationId xmlns:a16="http://schemas.microsoft.com/office/drawing/2014/main" id="{0E66EBA4-1B6C-0172-55A5-1C5E7A243594}"/>
+            </a:ext>
+          </a:extLst>
+        </p:cNvPr>
+        <p:cNvGrpSpPr/>
+        <p:nvPr/>
+      </p:nvGrpSpPr>
+      <p:grpSpPr>
+        <a:xfrm>
+          <a:off x="0" y="0"/>
+          <a:ext cx="0" cy="0"/>
+          <a:chOff x="0" y="0"/>
+          <a:chExt cx="0" cy="0"/>
+        </a:xfrm>
+      </p:grpSpPr>
+      <p:sp>
+        <p:nvSpPr>
+          <p:cNvPr id="3" name="Oval 2">
+            <a:extLst>
+              <a:ext uri="{FF2B5EF4-FFF2-40B4-BE49-F238E27FC236}">
+                <a16:creationId xmlns:a16="http://schemas.microsoft.com/office/drawing/2014/main" id="{9FC81907-C345-5FF3-D356-7848FFF64D2F}"/>
+              </a:ext>
+            </a:extLst>
+          </p:cNvPr>
+          <p:cNvSpPr/>
+          <p:nvPr/>
+        </p:nvSpPr>
+        <p:spPr>
+          <a:xfrm>
+            <a:off x="838473" y="2626468"/>
+            <a:ext cx="466928" cy="466928"/>
+          </a:xfrm>
+          <a:prstGeom prst="ellipse">
+            <a:avLst/>
+          </a:prstGeom>
+          <a:solidFill>
+            <a:schemeClr val="accent3">
+              <a:lumMod val="40000"/>
+              <a:lumOff val="60000"/>
+            </a:schemeClr>
+          </a:solidFill>
+          <a:ln w="38100"/>
+        </p:spPr>
+        <p:style>
+          <a:lnRef idx="2">
+            <a:schemeClr val="accent1">
+              <a:shade val="15000"/>
+            </a:schemeClr>
+          </a:lnRef>
+          <a:fillRef idx="1">
+            <a:schemeClr val="accent1"/>
+          </a:fillRef>
+          <a:effectRef idx="0">
+            <a:schemeClr val="accent1"/>
+          </a:effectRef>
+          <a:fontRef idx="minor">
+            <a:schemeClr val="lt1"/>
+          </a:fontRef>
+        </p:style>
+        <p:txBody>
+          <a:bodyPr rtlCol="0" anchor="ctr"/>
+          <a:lstStyle/>
+          <a:p>
+            <a:pPr algn="ctr"/>
+            <a:endParaRPr lang="en-US"/>
+          </a:p>
+        </p:txBody>
+      </p:sp>
+      <p:sp>
+        <p:nvSpPr>
+          <p:cNvPr id="4" name="Oval 3">
+            <a:extLst>
+              <a:ext uri="{FF2B5EF4-FFF2-40B4-BE49-F238E27FC236}">
+                <a16:creationId xmlns:a16="http://schemas.microsoft.com/office/drawing/2014/main" id="{AAA4DED4-10A2-DA60-57D6-C46474E9D276}"/>
+              </a:ext>
+            </a:extLst>
+          </p:cNvPr>
+          <p:cNvSpPr/>
+          <p:nvPr/>
+        </p:nvSpPr>
+        <p:spPr>
+          <a:xfrm>
+            <a:off x="1524273" y="2626468"/>
+            <a:ext cx="466928" cy="466928"/>
+          </a:xfrm>
+          <a:prstGeom prst="ellipse">
+            <a:avLst/>
+          </a:prstGeom>
+          <a:solidFill>
+            <a:schemeClr val="accent3">
+              <a:lumMod val="40000"/>
+              <a:lumOff val="60000"/>
+            </a:schemeClr>
+          </a:solidFill>
+          <a:ln w="38100"/>
+        </p:spPr>
+        <p:style>
+          <a:lnRef idx="2">
+            <a:schemeClr val="accent1">
+              <a:shade val="15000"/>
+            </a:schemeClr>
+          </a:lnRef>
+          <a:fillRef idx="1">
+            <a:schemeClr val="accent1"/>
+          </a:fillRef>
+          <a:effectRef idx="0">
+            <a:schemeClr val="accent1"/>
+          </a:effectRef>
+          <a:fontRef idx="minor">
+            <a:schemeClr val="lt1"/>
+          </a:fontRef>
+        </p:style>
+        <p:txBody>
+          <a:bodyPr rtlCol="0" anchor="ctr"/>
+          <a:lstStyle/>
+          <a:p>
+            <a:pPr algn="ctr"/>
+            <a:endParaRPr lang="en-US"/>
+          </a:p>
+        </p:txBody>
+      </p:sp>
+      <p:sp>
+        <p:nvSpPr>
+          <p:cNvPr id="5" name="Oval 4">
+            <a:extLst>
+              <a:ext uri="{FF2B5EF4-FFF2-40B4-BE49-F238E27FC236}">
+                <a16:creationId xmlns:a16="http://schemas.microsoft.com/office/drawing/2014/main" id="{805101AC-2FEE-EBFB-D981-B4D8E39EB582}"/>
+              </a:ext>
+            </a:extLst>
+          </p:cNvPr>
+          <p:cNvSpPr/>
+          <p:nvPr/>
+        </p:nvSpPr>
+        <p:spPr>
+          <a:xfrm>
+            <a:off x="2210073" y="2626468"/>
+            <a:ext cx="466928" cy="466928"/>
+          </a:xfrm>
+          <a:prstGeom prst="ellipse">
+            <a:avLst/>
+          </a:prstGeom>
+          <a:solidFill>
+            <a:schemeClr val="accent3">
+              <a:lumMod val="40000"/>
+              <a:lumOff val="60000"/>
+            </a:schemeClr>
+          </a:solidFill>
+          <a:ln w="38100"/>
+        </p:spPr>
+        <p:style>
+          <a:lnRef idx="2">
+            <a:schemeClr val="accent1">
+              <a:shade val="15000"/>
+            </a:schemeClr>
+          </a:lnRef>
+          <a:fillRef idx="1">
+            <a:schemeClr val="accent1"/>
+          </a:fillRef>
+          <a:effectRef idx="0">
+            <a:schemeClr val="accent1"/>
+          </a:effectRef>
+          <a:fontRef idx="minor">
+            <a:schemeClr val="lt1"/>
+          </a:fontRef>
+        </p:style>
+        <p:txBody>
+          <a:bodyPr rtlCol="0" anchor="ctr"/>
+          <a:lstStyle/>
+          <a:p>
+            <a:pPr algn="ctr"/>
+            <a:endParaRPr lang="en-US"/>
+          </a:p>
+        </p:txBody>
+      </p:sp>
+      <p:sp>
+        <p:nvSpPr>
+          <p:cNvPr id="6" name="Oval 5">
+            <a:extLst>
+              <a:ext uri="{FF2B5EF4-FFF2-40B4-BE49-F238E27FC236}">
+                <a16:creationId xmlns:a16="http://schemas.microsoft.com/office/drawing/2014/main" id="{3CE74335-859E-8F15-D45E-D973790F48C9}"/>
+              </a:ext>
+            </a:extLst>
+          </p:cNvPr>
+          <p:cNvSpPr/>
+          <p:nvPr/>
+        </p:nvSpPr>
+        <p:spPr>
+          <a:xfrm>
+            <a:off x="2895873" y="2626468"/>
+            <a:ext cx="466928" cy="466928"/>
+          </a:xfrm>
+          <a:prstGeom prst="ellipse">
+            <a:avLst/>
+          </a:prstGeom>
+          <a:solidFill>
+            <a:schemeClr val="accent3">
+              <a:lumMod val="40000"/>
+              <a:lumOff val="60000"/>
+            </a:schemeClr>
+          </a:solidFill>
+          <a:ln w="38100"/>
+        </p:spPr>
+        <p:style>
+          <a:lnRef idx="2">
+            <a:schemeClr val="accent1">
+              <a:shade val="15000"/>
+            </a:schemeClr>
+          </a:lnRef>
+          <a:fillRef idx="1">
+            <a:schemeClr val="accent1"/>
+          </a:fillRef>
+          <a:effectRef idx="0">
+            <a:schemeClr val="accent1"/>
+          </a:effectRef>
+          <a:fontRef idx="minor">
+            <a:schemeClr val="lt1"/>
+          </a:fontRef>
+        </p:style>
+        <p:txBody>
+          <a:bodyPr rtlCol="0" anchor="ctr"/>
+          <a:lstStyle/>
+          <a:p>
+            <a:pPr algn="ctr"/>
+            <a:endParaRPr lang="en-US"/>
+          </a:p>
+        </p:txBody>
+      </p:sp>
+      <p:sp>
+        <p:nvSpPr>
+          <p:cNvPr id="7" name="Oval 6">
+            <a:extLst>
+              <a:ext uri="{FF2B5EF4-FFF2-40B4-BE49-F238E27FC236}">
+                <a16:creationId xmlns:a16="http://schemas.microsoft.com/office/drawing/2014/main" id="{203A190A-206D-5D0A-864C-19EFBE5E8DC7}"/>
+              </a:ext>
+            </a:extLst>
+          </p:cNvPr>
+          <p:cNvSpPr/>
+          <p:nvPr/>
+        </p:nvSpPr>
+        <p:spPr>
+          <a:xfrm>
+            <a:off x="838473" y="3294434"/>
+            <a:ext cx="466928" cy="466928"/>
+          </a:xfrm>
+          <a:prstGeom prst="ellipse">
+            <a:avLst/>
+          </a:prstGeom>
+          <a:solidFill>
+            <a:schemeClr val="accent1">
+              <a:lumMod val="40000"/>
+              <a:lumOff val="60000"/>
+            </a:schemeClr>
+          </a:solidFill>
+          <a:ln w="38100"/>
+        </p:spPr>
+        <p:style>
+          <a:lnRef idx="2">
+            <a:schemeClr val="accent1">
+              <a:shade val="15000"/>
+            </a:schemeClr>
+          </a:lnRef>
+          <a:fillRef idx="1">
+            <a:schemeClr val="accent1"/>
+          </a:fillRef>
+          <a:effectRef idx="0">
+            <a:schemeClr val="accent1"/>
+          </a:effectRef>
+          <a:fontRef idx="minor">
+            <a:schemeClr val="lt1"/>
+          </a:fontRef>
+        </p:style>
+        <p:txBody>
+          <a:bodyPr rtlCol="0" anchor="ctr"/>
+          <a:lstStyle/>
+          <a:p>
+            <a:pPr algn="ctr"/>
+            <a:endParaRPr lang="en-US"/>
+          </a:p>
+        </p:txBody>
+      </p:sp>
+      <p:sp>
+        <p:nvSpPr>
+          <p:cNvPr id="8" name="Oval 7">
+            <a:extLst>
+              <a:ext uri="{FF2B5EF4-FFF2-40B4-BE49-F238E27FC236}">
+                <a16:creationId xmlns:a16="http://schemas.microsoft.com/office/drawing/2014/main" id="{5B509CC0-80A8-2739-4FF5-40CD5A875A09}"/>
+              </a:ext>
+            </a:extLst>
+          </p:cNvPr>
+          <p:cNvSpPr/>
+          <p:nvPr/>
+        </p:nvSpPr>
+        <p:spPr>
+          <a:xfrm>
+            <a:off x="1524273" y="3294434"/>
+            <a:ext cx="466928" cy="466928"/>
+          </a:xfrm>
+          <a:prstGeom prst="ellipse">
+            <a:avLst/>
+          </a:prstGeom>
+          <a:solidFill>
+            <a:schemeClr val="accent3">
+              <a:lumMod val="40000"/>
+              <a:lumOff val="60000"/>
+            </a:schemeClr>
+          </a:solidFill>
+          <a:ln w="38100"/>
+        </p:spPr>
+        <p:style>
+          <a:lnRef idx="2">
+            <a:schemeClr val="accent1">
+              <a:shade val="15000"/>
+            </a:schemeClr>
+          </a:lnRef>
+          <a:fillRef idx="1">
+            <a:schemeClr val="accent1"/>
+          </a:fillRef>
+          <a:effectRef idx="0">
+            <a:schemeClr val="accent1"/>
+          </a:effectRef>
+          <a:fontRef idx="minor">
+            <a:schemeClr val="lt1"/>
+          </a:fontRef>
+        </p:style>
+        <p:txBody>
+          <a:bodyPr rtlCol="0" anchor="ctr"/>
+          <a:lstStyle/>
+          <a:p>
+            <a:pPr algn="ctr"/>
+            <a:endParaRPr lang="en-US"/>
+          </a:p>
+        </p:txBody>
+      </p:sp>
+      <p:sp>
+        <p:nvSpPr>
+          <p:cNvPr id="9" name="Oval 8">
+            <a:extLst>
+              <a:ext uri="{FF2B5EF4-FFF2-40B4-BE49-F238E27FC236}">
+                <a16:creationId xmlns:a16="http://schemas.microsoft.com/office/drawing/2014/main" id="{D5D32826-5061-192B-CF3B-9B1AC86473FE}"/>
+              </a:ext>
+            </a:extLst>
+          </p:cNvPr>
+          <p:cNvSpPr/>
+          <p:nvPr/>
+        </p:nvSpPr>
+        <p:spPr>
+          <a:xfrm>
+            <a:off x="2210073" y="3294434"/>
+            <a:ext cx="466928" cy="466928"/>
+          </a:xfrm>
+          <a:prstGeom prst="ellipse">
+            <a:avLst/>
+          </a:prstGeom>
+          <a:solidFill>
+            <a:schemeClr val="accent3">
+              <a:lumMod val="40000"/>
+              <a:lumOff val="60000"/>
+            </a:schemeClr>
+          </a:solidFill>
+          <a:ln w="38100"/>
+        </p:spPr>
+        <p:style>
+          <a:lnRef idx="2">
+            <a:schemeClr val="accent1">
+              <a:shade val="15000"/>
+            </a:schemeClr>
+          </a:lnRef>
+          <a:fillRef idx="1">
+            <a:schemeClr val="accent1"/>
+          </a:fillRef>
+          <a:effectRef idx="0">
+            <a:schemeClr val="accent1"/>
+          </a:effectRef>
+          <a:fontRef idx="minor">
+            <a:schemeClr val="lt1"/>
+          </a:fontRef>
+        </p:style>
+        <p:txBody>
+          <a:bodyPr rtlCol="0" anchor="ctr"/>
+          <a:lstStyle/>
+          <a:p>
+            <a:pPr algn="ctr"/>
+            <a:endParaRPr lang="en-US"/>
+          </a:p>
+        </p:txBody>
+      </p:sp>
+      <p:sp>
+        <p:nvSpPr>
+          <p:cNvPr id="10" name="Oval 9">
+            <a:extLst>
+              <a:ext uri="{FF2B5EF4-FFF2-40B4-BE49-F238E27FC236}">
+                <a16:creationId xmlns:a16="http://schemas.microsoft.com/office/drawing/2014/main" id="{7C9D985D-19DD-936E-0486-FAA612490825}"/>
+              </a:ext>
+            </a:extLst>
+          </p:cNvPr>
+          <p:cNvSpPr/>
+          <p:nvPr/>
+        </p:nvSpPr>
+        <p:spPr>
+          <a:xfrm>
+            <a:off x="2895873" y="3294434"/>
+            <a:ext cx="466928" cy="466928"/>
+          </a:xfrm>
+          <a:prstGeom prst="ellipse">
+            <a:avLst/>
+          </a:prstGeom>
+          <a:solidFill>
+            <a:schemeClr val="accent3">
+              <a:lumMod val="40000"/>
+              <a:lumOff val="60000"/>
+            </a:schemeClr>
+          </a:solidFill>
+          <a:ln w="38100"/>
+        </p:spPr>
+        <p:style>
+          <a:lnRef idx="2">
+            <a:schemeClr val="accent1">
+              <a:shade val="15000"/>
+            </a:schemeClr>
+          </a:lnRef>
+          <a:fillRef idx="1">
+            <a:schemeClr val="accent1"/>
+          </a:fillRef>
+          <a:effectRef idx="0">
+            <a:schemeClr val="accent1"/>
+          </a:effectRef>
+          <a:fontRef idx="minor">
+            <a:schemeClr val="lt1"/>
+          </a:fontRef>
+        </p:style>
+        <p:txBody>
+          <a:bodyPr rtlCol="0" anchor="ctr"/>
+          <a:lstStyle/>
+          <a:p>
+            <a:pPr algn="ctr"/>
+            <a:endParaRPr lang="en-US"/>
+          </a:p>
+        </p:txBody>
+      </p:sp>
+      <p:sp>
+        <p:nvSpPr>
+          <p:cNvPr id="11" name="Oval 10">
+            <a:extLst>
+              <a:ext uri="{FF2B5EF4-FFF2-40B4-BE49-F238E27FC236}">
+                <a16:creationId xmlns:a16="http://schemas.microsoft.com/office/drawing/2014/main" id="{20B719C9-97D8-761F-099B-0F91FE4775EC}"/>
+              </a:ext>
+            </a:extLst>
+          </p:cNvPr>
+          <p:cNvSpPr/>
+          <p:nvPr/>
+        </p:nvSpPr>
+        <p:spPr>
+          <a:xfrm>
+            <a:off x="838473" y="3962400"/>
+            <a:ext cx="466928" cy="466928"/>
+          </a:xfrm>
+          <a:prstGeom prst="ellipse">
+            <a:avLst/>
+          </a:prstGeom>
+          <a:solidFill>
+            <a:schemeClr val="accent1">
+              <a:lumMod val="40000"/>
+              <a:lumOff val="60000"/>
+            </a:schemeClr>
+          </a:solidFill>
+          <a:ln w="38100"/>
+        </p:spPr>
+        <p:style>
+          <a:lnRef idx="2">
+            <a:schemeClr val="accent1">
+              <a:shade val="15000"/>
+            </a:schemeClr>
+          </a:lnRef>
+          <a:fillRef idx="1">
+            <a:schemeClr val="accent1"/>
+          </a:fillRef>
+          <a:effectRef idx="0">
+            <a:schemeClr val="accent1"/>
+          </a:effectRef>
+          <a:fontRef idx="minor">
+            <a:schemeClr val="lt1"/>
+          </a:fontRef>
+        </p:style>
+        <p:txBody>
+          <a:bodyPr rtlCol="0" anchor="ctr"/>
+          <a:lstStyle/>
+          <a:p>
+            <a:pPr algn="ctr"/>
+            <a:endParaRPr lang="en-US"/>
+          </a:p>
+        </p:txBody>
+      </p:sp>
+      <p:sp>
+        <p:nvSpPr>
+          <p:cNvPr id="12" name="Oval 11">
+            <a:extLst>
+              <a:ext uri="{FF2B5EF4-FFF2-40B4-BE49-F238E27FC236}">
+                <a16:creationId xmlns:a16="http://schemas.microsoft.com/office/drawing/2014/main" id="{6865363A-CC8A-C11D-1431-2754154E5BE0}"/>
+              </a:ext>
+            </a:extLst>
+          </p:cNvPr>
+          <p:cNvSpPr/>
+          <p:nvPr/>
+        </p:nvSpPr>
+        <p:spPr>
+          <a:xfrm>
+            <a:off x="1524273" y="3962400"/>
+            <a:ext cx="466928" cy="466928"/>
+          </a:xfrm>
+          <a:prstGeom prst="ellipse">
+            <a:avLst/>
+          </a:prstGeom>
+          <a:solidFill>
+            <a:schemeClr val="accent1">
+              <a:lumMod val="40000"/>
+              <a:lumOff val="60000"/>
+            </a:schemeClr>
+          </a:solidFill>
+          <a:ln w="38100"/>
+        </p:spPr>
+        <p:style>
+          <a:lnRef idx="2">
+            <a:schemeClr val="accent1">
+              <a:shade val="15000"/>
+            </a:schemeClr>
+          </a:lnRef>
+          <a:fillRef idx="1">
+            <a:schemeClr val="accent1"/>
+          </a:fillRef>
+          <a:effectRef idx="0">
+            <a:schemeClr val="accent1"/>
+          </a:effectRef>
+          <a:fontRef idx="minor">
+            <a:schemeClr val="lt1"/>
+          </a:fontRef>
+        </p:style>
+        <p:txBody>
+          <a:bodyPr rtlCol="0" anchor="ctr"/>
+          <a:lstStyle/>
+          <a:p>
+            <a:pPr algn="ctr"/>
+            <a:endParaRPr lang="en-US"/>
+          </a:p>
+        </p:txBody>
+      </p:sp>
+      <p:sp>
+        <p:nvSpPr>
+          <p:cNvPr id="13" name="Oval 12">
+            <a:extLst>
+              <a:ext uri="{FF2B5EF4-FFF2-40B4-BE49-F238E27FC236}">
+                <a16:creationId xmlns:a16="http://schemas.microsoft.com/office/drawing/2014/main" id="{C38DCA7A-97CA-44E0-E1FB-FDE7AC95E924}"/>
+              </a:ext>
+            </a:extLst>
+          </p:cNvPr>
+          <p:cNvSpPr/>
+          <p:nvPr/>
+        </p:nvSpPr>
+        <p:spPr>
+          <a:xfrm>
+            <a:off x="2210073" y="3962400"/>
+            <a:ext cx="466928" cy="466928"/>
+          </a:xfrm>
+          <a:prstGeom prst="ellipse">
+            <a:avLst/>
+          </a:prstGeom>
+          <a:solidFill>
+            <a:schemeClr val="accent3">
+              <a:lumMod val="40000"/>
+              <a:lumOff val="60000"/>
+            </a:schemeClr>
+          </a:solidFill>
+          <a:ln w="38100"/>
+        </p:spPr>
+        <p:style>
+          <a:lnRef idx="2">
+            <a:schemeClr val="accent1">
+              <a:shade val="15000"/>
+            </a:schemeClr>
+          </a:lnRef>
+          <a:fillRef idx="1">
+            <a:schemeClr val="accent1"/>
+          </a:fillRef>
+          <a:effectRef idx="0">
+            <a:schemeClr val="accent1"/>
+          </a:effectRef>
+          <a:fontRef idx="minor">
+            <a:schemeClr val="lt1"/>
+          </a:fontRef>
+        </p:style>
+        <p:txBody>
+          <a:bodyPr rtlCol="0" anchor="ctr"/>
+          <a:lstStyle/>
+          <a:p>
+            <a:pPr algn="ctr"/>
+            <a:endParaRPr lang="en-US"/>
+          </a:p>
+        </p:txBody>
+      </p:sp>
+      <p:sp>
+        <p:nvSpPr>
+          <p:cNvPr id="14" name="Oval 13">
+            <a:extLst>
+              <a:ext uri="{FF2B5EF4-FFF2-40B4-BE49-F238E27FC236}">
+                <a16:creationId xmlns:a16="http://schemas.microsoft.com/office/drawing/2014/main" id="{AB0F939C-F2F5-6FBA-CCFA-EAFE930DD1D8}"/>
+              </a:ext>
+            </a:extLst>
+          </p:cNvPr>
+          <p:cNvSpPr/>
+          <p:nvPr/>
+        </p:nvSpPr>
+        <p:spPr>
+          <a:xfrm>
+            <a:off x="2895873" y="3962400"/>
+            <a:ext cx="466928" cy="466928"/>
+          </a:xfrm>
+          <a:prstGeom prst="ellipse">
+            <a:avLst/>
+          </a:prstGeom>
+          <a:solidFill>
+            <a:schemeClr val="accent3">
+              <a:lumMod val="40000"/>
+              <a:lumOff val="60000"/>
+            </a:schemeClr>
+          </a:solidFill>
+          <a:ln w="38100"/>
+        </p:spPr>
+        <p:style>
+          <a:lnRef idx="2">
+            <a:schemeClr val="accent1">
+              <a:shade val="15000"/>
+            </a:schemeClr>
+          </a:lnRef>
+          <a:fillRef idx="1">
+            <a:schemeClr val="accent1"/>
+          </a:fillRef>
+          <a:effectRef idx="0">
+            <a:schemeClr val="accent1"/>
+          </a:effectRef>
+          <a:fontRef idx="minor">
+            <a:schemeClr val="lt1"/>
+          </a:fontRef>
+        </p:style>
+        <p:txBody>
+          <a:bodyPr rtlCol="0" anchor="ctr"/>
+          <a:lstStyle/>
+          <a:p>
+            <a:pPr algn="ctr"/>
+            <a:endParaRPr lang="en-US"/>
+          </a:p>
+        </p:txBody>
+      </p:sp>
+      <p:sp>
+        <p:nvSpPr>
+          <p:cNvPr id="15" name="Oval 14">
+            <a:extLst>
+              <a:ext uri="{FF2B5EF4-FFF2-40B4-BE49-F238E27FC236}">
+                <a16:creationId xmlns:a16="http://schemas.microsoft.com/office/drawing/2014/main" id="{FC8DE9B8-2C88-1237-B962-EBC413C6E7F6}"/>
+              </a:ext>
+            </a:extLst>
+          </p:cNvPr>
+          <p:cNvSpPr/>
+          <p:nvPr/>
+        </p:nvSpPr>
+        <p:spPr>
+          <a:xfrm>
+            <a:off x="838473" y="4630366"/>
+            <a:ext cx="466928" cy="466928"/>
+          </a:xfrm>
+          <a:prstGeom prst="ellipse">
+            <a:avLst/>
+          </a:prstGeom>
+          <a:solidFill>
+            <a:schemeClr val="accent1">
+              <a:lumMod val="40000"/>
+              <a:lumOff val="60000"/>
+            </a:schemeClr>
+          </a:solidFill>
+          <a:ln w="38100"/>
+        </p:spPr>
+        <p:style>
+          <a:lnRef idx="2">
+            <a:schemeClr val="accent1">
+              <a:shade val="15000"/>
+            </a:schemeClr>
+          </a:lnRef>
+          <a:fillRef idx="1">
+            <a:schemeClr val="accent1"/>
+          </a:fillRef>
+          <a:effectRef idx="0">
+            <a:schemeClr val="accent1"/>
+          </a:effectRef>
+          <a:fontRef idx="minor">
+            <a:schemeClr val="lt1"/>
+          </a:fontRef>
+        </p:style>
+        <p:txBody>
+          <a:bodyPr rtlCol="0" anchor="ctr"/>
+          <a:lstStyle/>
+          <a:p>
+            <a:pPr algn="ctr"/>
+            <a:endParaRPr lang="en-US"/>
+          </a:p>
+        </p:txBody>
+      </p:sp>
+      <p:sp>
+        <p:nvSpPr>
+          <p:cNvPr id="16" name="Oval 15">
+            <a:extLst>
+              <a:ext uri="{FF2B5EF4-FFF2-40B4-BE49-F238E27FC236}">
+                <a16:creationId xmlns:a16="http://schemas.microsoft.com/office/drawing/2014/main" id="{B83CCC3D-B633-5739-57B2-DF06EA55D88A}"/>
+              </a:ext>
+            </a:extLst>
+          </p:cNvPr>
+          <p:cNvSpPr/>
+          <p:nvPr/>
+        </p:nvSpPr>
+        <p:spPr>
+          <a:xfrm>
+            <a:off x="1524273" y="4630366"/>
+            <a:ext cx="466928" cy="466928"/>
+          </a:xfrm>
+          <a:prstGeom prst="ellipse">
+            <a:avLst/>
+          </a:prstGeom>
+          <a:solidFill>
+            <a:schemeClr val="accent1">
+              <a:lumMod val="40000"/>
+              <a:lumOff val="60000"/>
+            </a:schemeClr>
+          </a:solidFill>
+          <a:ln w="38100"/>
+        </p:spPr>
+        <p:style>
+          <a:lnRef idx="2">
+            <a:schemeClr val="accent1">
+              <a:shade val="15000"/>
+            </a:schemeClr>
+          </a:lnRef>
+          <a:fillRef idx="1">
+            <a:schemeClr val="accent1"/>
+          </a:fillRef>
+          <a:effectRef idx="0">
+            <a:schemeClr val="accent1"/>
+          </a:effectRef>
+          <a:fontRef idx="minor">
+            <a:schemeClr val="lt1"/>
+          </a:fontRef>
+        </p:style>
+        <p:txBody>
+          <a:bodyPr rtlCol="0" anchor="ctr"/>
+          <a:lstStyle/>
+          <a:p>
+            <a:pPr algn="ctr"/>
+            <a:endParaRPr lang="en-US"/>
+          </a:p>
+        </p:txBody>
+      </p:sp>
+      <p:sp>
+        <p:nvSpPr>
+          <p:cNvPr id="17" name="Oval 16">
+            <a:extLst>
+              <a:ext uri="{FF2B5EF4-FFF2-40B4-BE49-F238E27FC236}">
+                <a16:creationId xmlns:a16="http://schemas.microsoft.com/office/drawing/2014/main" id="{E9247FF3-2590-EBE2-D4C7-1A2F050FCAB4}"/>
+              </a:ext>
+            </a:extLst>
+          </p:cNvPr>
+          <p:cNvSpPr/>
+          <p:nvPr/>
+        </p:nvSpPr>
+        <p:spPr>
+          <a:xfrm>
+            <a:off x="2210073" y="4630366"/>
+            <a:ext cx="466928" cy="466928"/>
+          </a:xfrm>
+          <a:prstGeom prst="ellipse">
+            <a:avLst/>
+          </a:prstGeom>
+          <a:solidFill>
+            <a:schemeClr val="accent1">
+              <a:lumMod val="40000"/>
+              <a:lumOff val="60000"/>
+            </a:schemeClr>
+          </a:solidFill>
+          <a:ln w="38100"/>
+        </p:spPr>
+        <p:style>
+          <a:lnRef idx="2">
+            <a:schemeClr val="accent1">
+              <a:shade val="15000"/>
+            </a:schemeClr>
+          </a:lnRef>
+          <a:fillRef idx="1">
+            <a:schemeClr val="accent1"/>
+          </a:fillRef>
+          <a:effectRef idx="0">
+            <a:schemeClr val="accent1"/>
+          </a:effectRef>
+          <a:fontRef idx="minor">
+            <a:schemeClr val="lt1"/>
+          </a:fontRef>
+        </p:style>
+        <p:txBody>
+          <a:bodyPr rtlCol="0" anchor="ctr"/>
+          <a:lstStyle/>
+          <a:p>
+            <a:pPr algn="ctr"/>
+            <a:endParaRPr lang="en-US"/>
+          </a:p>
+        </p:txBody>
+      </p:sp>
+      <p:sp>
+        <p:nvSpPr>
+          <p:cNvPr id="18" name="Oval 17">
+            <a:extLst>
+              <a:ext uri="{FF2B5EF4-FFF2-40B4-BE49-F238E27FC236}">
+                <a16:creationId xmlns:a16="http://schemas.microsoft.com/office/drawing/2014/main" id="{87DF581F-5725-2884-75B1-FCA527AE9E0C}"/>
+              </a:ext>
+            </a:extLst>
+          </p:cNvPr>
+          <p:cNvSpPr/>
+          <p:nvPr/>
+        </p:nvSpPr>
+        <p:spPr>
+          <a:xfrm>
+            <a:off x="2895873" y="4630366"/>
+            <a:ext cx="466928" cy="466928"/>
+          </a:xfrm>
+          <a:prstGeom prst="ellipse">
+            <a:avLst/>
+          </a:prstGeom>
+          <a:solidFill>
+            <a:schemeClr val="accent3">
+              <a:lumMod val="40000"/>
+              <a:lumOff val="60000"/>
+            </a:schemeClr>
+          </a:solidFill>
+          <a:ln w="38100"/>
+        </p:spPr>
+        <p:style>
+          <a:lnRef idx="2">
+            <a:schemeClr val="accent1">
+              <a:shade val="15000"/>
+            </a:schemeClr>
+          </a:lnRef>
+          <a:fillRef idx="1">
+            <a:schemeClr val="accent1"/>
+          </a:fillRef>
+          <a:effectRef idx="0">
+            <a:schemeClr val="accent1"/>
+          </a:effectRef>
+          <a:fontRef idx="minor">
+            <a:schemeClr val="lt1"/>
+          </a:fontRef>
+        </p:style>
+        <p:txBody>
+          <a:bodyPr rtlCol="0" anchor="ctr"/>
+          <a:lstStyle/>
+          <a:p>
+            <a:pPr algn="ctr"/>
+            <a:endParaRPr lang="en-US"/>
+          </a:p>
+        </p:txBody>
+      </p:sp>
+      <p:sp>
+        <p:nvSpPr>
+          <p:cNvPr id="19" name="Oval 18">
+            <a:extLst>
+              <a:ext uri="{FF2B5EF4-FFF2-40B4-BE49-F238E27FC236}">
+                <a16:creationId xmlns:a16="http://schemas.microsoft.com/office/drawing/2014/main" id="{96BB0C0B-4058-D59B-63DC-DE39C895DB9F}"/>
+              </a:ext>
+            </a:extLst>
+          </p:cNvPr>
+          <p:cNvSpPr/>
+          <p:nvPr/>
+        </p:nvSpPr>
+        <p:spPr>
+          <a:xfrm>
+            <a:off x="838473" y="5298332"/>
+            <a:ext cx="466928" cy="466928"/>
+          </a:xfrm>
+          <a:prstGeom prst="ellipse">
+            <a:avLst/>
+          </a:prstGeom>
+          <a:solidFill>
+            <a:schemeClr val="accent1">
+              <a:lumMod val="40000"/>
+              <a:lumOff val="60000"/>
+            </a:schemeClr>
+          </a:solidFill>
+          <a:ln w="38100"/>
+        </p:spPr>
+        <p:style>
+          <a:lnRef idx="2">
+            <a:schemeClr val="accent1">
+              <a:shade val="15000"/>
+            </a:schemeClr>
+          </a:lnRef>
+          <a:fillRef idx="1">
+            <a:schemeClr val="accent1"/>
+          </a:fillRef>
+          <a:effectRef idx="0">
+            <a:schemeClr val="accent1"/>
+          </a:effectRef>
+          <a:fontRef idx="minor">
+            <a:schemeClr val="lt1"/>
+          </a:fontRef>
+        </p:style>
+        <p:txBody>
+          <a:bodyPr rtlCol="0" anchor="ctr"/>
+          <a:lstStyle/>
+          <a:p>
+            <a:pPr algn="ctr"/>
+            <a:endParaRPr lang="en-US"/>
+          </a:p>
+        </p:txBody>
+      </p:sp>
+      <p:sp>
+        <p:nvSpPr>
+          <p:cNvPr id="20" name="Oval 19">
+            <a:extLst>
+              <a:ext uri="{FF2B5EF4-FFF2-40B4-BE49-F238E27FC236}">
+                <a16:creationId xmlns:a16="http://schemas.microsoft.com/office/drawing/2014/main" id="{B92E9603-C69D-0434-6422-939A18F5CDC5}"/>
+              </a:ext>
+            </a:extLst>
+          </p:cNvPr>
+          <p:cNvSpPr/>
+          <p:nvPr/>
+        </p:nvSpPr>
+        <p:spPr>
+          <a:xfrm>
+            <a:off x="1524273" y="5298332"/>
+            <a:ext cx="466928" cy="466928"/>
+          </a:xfrm>
+          <a:prstGeom prst="ellipse">
+            <a:avLst/>
+          </a:prstGeom>
+          <a:solidFill>
+            <a:schemeClr val="accent1">
+              <a:lumMod val="40000"/>
+              <a:lumOff val="60000"/>
+            </a:schemeClr>
+          </a:solidFill>
+          <a:ln w="38100"/>
+        </p:spPr>
+        <p:style>
+          <a:lnRef idx="2">
+            <a:schemeClr val="accent1">
+              <a:shade val="15000"/>
+            </a:schemeClr>
+          </a:lnRef>
+          <a:fillRef idx="1">
+            <a:schemeClr val="accent1"/>
+          </a:fillRef>
+          <a:effectRef idx="0">
+            <a:schemeClr val="accent1"/>
+          </a:effectRef>
+          <a:fontRef idx="minor">
+            <a:schemeClr val="lt1"/>
+          </a:fontRef>
+        </p:style>
+        <p:txBody>
+          <a:bodyPr rtlCol="0" anchor="ctr"/>
+          <a:lstStyle/>
+          <a:p>
+            <a:pPr algn="ctr"/>
+            <a:endParaRPr lang="en-US"/>
+          </a:p>
+        </p:txBody>
+      </p:sp>
+      <p:sp>
+        <p:nvSpPr>
+          <p:cNvPr id="21" name="Oval 20">
+            <a:extLst>
+              <a:ext uri="{FF2B5EF4-FFF2-40B4-BE49-F238E27FC236}">
+                <a16:creationId xmlns:a16="http://schemas.microsoft.com/office/drawing/2014/main" id="{0FADEAD8-8984-0AB4-4FAC-C3FE4C400624}"/>
+              </a:ext>
+            </a:extLst>
+          </p:cNvPr>
+          <p:cNvSpPr/>
+          <p:nvPr/>
+        </p:nvSpPr>
+        <p:spPr>
+          <a:xfrm>
+            <a:off x="2210073" y="5298332"/>
+            <a:ext cx="466928" cy="466928"/>
+          </a:xfrm>
+          <a:prstGeom prst="ellipse">
+            <a:avLst/>
+          </a:prstGeom>
+          <a:solidFill>
+            <a:schemeClr val="accent1">
+              <a:lumMod val="40000"/>
+              <a:lumOff val="60000"/>
+            </a:schemeClr>
+          </a:solidFill>
+          <a:ln w="38100"/>
+        </p:spPr>
+        <p:style>
+          <a:lnRef idx="2">
+            <a:schemeClr val="accent1">
+              <a:shade val="15000"/>
+            </a:schemeClr>
+          </a:lnRef>
+          <a:fillRef idx="1">
+            <a:schemeClr val="accent1"/>
+          </a:fillRef>
+          <a:effectRef idx="0">
+            <a:schemeClr val="accent1"/>
+          </a:effectRef>
+          <a:fontRef idx="minor">
+            <a:schemeClr val="lt1"/>
+          </a:fontRef>
+        </p:style>
+        <p:txBody>
+          <a:bodyPr rtlCol="0" anchor="ctr"/>
+          <a:lstStyle/>
+          <a:p>
+            <a:pPr algn="ctr"/>
+            <a:endParaRPr lang="en-US"/>
+          </a:p>
+        </p:txBody>
+      </p:sp>
+      <p:sp>
+        <p:nvSpPr>
+          <p:cNvPr id="22" name="Oval 21">
+            <a:extLst>
+              <a:ext uri="{FF2B5EF4-FFF2-40B4-BE49-F238E27FC236}">
+                <a16:creationId xmlns:a16="http://schemas.microsoft.com/office/drawing/2014/main" id="{03B10888-8ACC-3FCC-9829-A698D9F4737B}"/>
+              </a:ext>
+            </a:extLst>
+          </p:cNvPr>
+          <p:cNvSpPr/>
+          <p:nvPr/>
+        </p:nvSpPr>
+        <p:spPr>
+          <a:xfrm>
+            <a:off x="2895873" y="5298332"/>
+            <a:ext cx="466928" cy="466928"/>
+          </a:xfrm>
+          <a:prstGeom prst="ellipse">
+            <a:avLst/>
+          </a:prstGeom>
+          <a:solidFill>
+            <a:schemeClr val="accent1">
+              <a:lumMod val="40000"/>
+              <a:lumOff val="60000"/>
+            </a:schemeClr>
+          </a:solidFill>
+          <a:ln w="38100"/>
+        </p:spPr>
+        <p:style>
+          <a:lnRef idx="2">
+            <a:schemeClr val="accent1">
+              <a:shade val="15000"/>
+            </a:schemeClr>
+          </a:lnRef>
+          <a:fillRef idx="1">
+            <a:schemeClr val="accent1"/>
+          </a:fillRef>
+          <a:effectRef idx="0">
+            <a:schemeClr val="accent1"/>
+          </a:effectRef>
+          <a:fontRef idx="minor">
+            <a:schemeClr val="lt1"/>
+          </a:fontRef>
+        </p:style>
+        <p:txBody>
+          <a:bodyPr rtlCol="0" anchor="ctr"/>
+          <a:lstStyle/>
+          <a:p>
+            <a:pPr algn="ctr"/>
+            <a:endParaRPr lang="en-US"/>
+          </a:p>
+        </p:txBody>
+      </p:sp>
+      <p:sp>
+        <p:nvSpPr>
+          <p:cNvPr id="27" name="TextBox 26">
+            <a:extLst>
+              <a:ext uri="{FF2B5EF4-FFF2-40B4-BE49-F238E27FC236}">
+                <a16:creationId xmlns:a16="http://schemas.microsoft.com/office/drawing/2014/main" id="{A332D0C5-8838-DEC0-4C44-D52FE117C701}"/>
+              </a:ext>
+            </a:extLst>
+          </p:cNvPr>
+          <p:cNvSpPr txBox="1"/>
+          <p:nvPr/>
+        </p:nvSpPr>
+        <p:spPr>
+          <a:xfrm>
+            <a:off x="203213" y="2599359"/>
+            <a:ext cx="479618" cy="523220"/>
+          </a:xfrm>
+          <a:prstGeom prst="rect">
+            <a:avLst/>
+          </a:prstGeom>
+          <a:noFill/>
+        </p:spPr>
+        <p:txBody>
+          <a:bodyPr wrap="none" rtlCol="0">
+            <a:spAutoFit/>
+          </a:bodyPr>
+          <a:lstStyle/>
+          <a:p>
+            <a:r>
+              <a:rPr lang="en-US" sz="2800" dirty="0"/>
+              <a:t>1.</a:t>
+            </a:r>
+          </a:p>
+        </p:txBody>
+      </p:sp>
+      <p:sp>
+        <p:nvSpPr>
+          <p:cNvPr id="28" name="TextBox 27">
+            <a:extLst>
+              <a:ext uri="{FF2B5EF4-FFF2-40B4-BE49-F238E27FC236}">
+                <a16:creationId xmlns:a16="http://schemas.microsoft.com/office/drawing/2014/main" id="{52D49977-A7BD-11AA-92D0-C2B177DE2EDC}"/>
+              </a:ext>
+            </a:extLst>
+          </p:cNvPr>
+          <p:cNvSpPr txBox="1"/>
+          <p:nvPr/>
+        </p:nvSpPr>
+        <p:spPr>
+          <a:xfrm>
+            <a:off x="203213" y="3266288"/>
+            <a:ext cx="479618" cy="523220"/>
+          </a:xfrm>
+          <a:prstGeom prst="rect">
+            <a:avLst/>
+          </a:prstGeom>
+          <a:noFill/>
+        </p:spPr>
+        <p:txBody>
+          <a:bodyPr wrap="none" rtlCol="0">
+            <a:spAutoFit/>
+          </a:bodyPr>
+          <a:lstStyle/>
+          <a:p>
+            <a:r>
+              <a:rPr lang="en-US" sz="2800" dirty="0"/>
+              <a:t>2.</a:t>
+            </a:r>
+          </a:p>
+        </p:txBody>
+      </p:sp>
+      <p:sp>
+        <p:nvSpPr>
+          <p:cNvPr id="29" name="TextBox 28">
+            <a:extLst>
+              <a:ext uri="{FF2B5EF4-FFF2-40B4-BE49-F238E27FC236}">
+                <a16:creationId xmlns:a16="http://schemas.microsoft.com/office/drawing/2014/main" id="{C556ADEE-1B37-AFCE-4D2A-23BB24C6535A}"/>
+              </a:ext>
+            </a:extLst>
+          </p:cNvPr>
+          <p:cNvSpPr txBox="1"/>
+          <p:nvPr/>
+        </p:nvSpPr>
+        <p:spPr>
+          <a:xfrm>
+            <a:off x="203213" y="3934254"/>
+            <a:ext cx="479618" cy="523220"/>
+          </a:xfrm>
+          <a:prstGeom prst="rect">
+            <a:avLst/>
+          </a:prstGeom>
+          <a:noFill/>
+        </p:spPr>
+        <p:txBody>
+          <a:bodyPr wrap="none" rtlCol="0">
+            <a:spAutoFit/>
+          </a:bodyPr>
+          <a:lstStyle/>
+          <a:p>
+            <a:r>
+              <a:rPr lang="en-US" sz="2800" dirty="0"/>
+              <a:t>3.</a:t>
+            </a:r>
+          </a:p>
+        </p:txBody>
+      </p:sp>
+      <p:sp>
+        <p:nvSpPr>
+          <p:cNvPr id="30" name="TextBox 29">
+            <a:extLst>
+              <a:ext uri="{FF2B5EF4-FFF2-40B4-BE49-F238E27FC236}">
+                <a16:creationId xmlns:a16="http://schemas.microsoft.com/office/drawing/2014/main" id="{D052885C-20B0-21DA-BC44-E1E48986F9E5}"/>
+              </a:ext>
+            </a:extLst>
+          </p:cNvPr>
+          <p:cNvSpPr txBox="1"/>
+          <p:nvPr/>
+        </p:nvSpPr>
+        <p:spPr>
+          <a:xfrm>
+            <a:off x="203213" y="4602220"/>
+            <a:ext cx="479618" cy="523220"/>
+          </a:xfrm>
+          <a:prstGeom prst="rect">
+            <a:avLst/>
+          </a:prstGeom>
+          <a:noFill/>
+        </p:spPr>
+        <p:txBody>
+          <a:bodyPr wrap="none" rtlCol="0">
+            <a:spAutoFit/>
+          </a:bodyPr>
+          <a:lstStyle/>
+          <a:p>
+            <a:r>
+              <a:rPr lang="en-US" sz="2800" dirty="0"/>
+              <a:t>4.</a:t>
+            </a:r>
+          </a:p>
+        </p:txBody>
+      </p:sp>
+      <p:sp>
+        <p:nvSpPr>
+          <p:cNvPr id="31" name="TextBox 30">
+            <a:extLst>
+              <a:ext uri="{FF2B5EF4-FFF2-40B4-BE49-F238E27FC236}">
+                <a16:creationId xmlns:a16="http://schemas.microsoft.com/office/drawing/2014/main" id="{39F63F61-D3D1-9356-E9A9-440EC9B0773A}"/>
+              </a:ext>
+            </a:extLst>
+          </p:cNvPr>
+          <p:cNvSpPr txBox="1"/>
+          <p:nvPr/>
+        </p:nvSpPr>
+        <p:spPr>
+          <a:xfrm>
+            <a:off x="203213" y="5270186"/>
+            <a:ext cx="479618" cy="523220"/>
+          </a:xfrm>
+          <a:prstGeom prst="rect">
+            <a:avLst/>
+          </a:prstGeom>
+          <a:noFill/>
+        </p:spPr>
+        <p:txBody>
+          <a:bodyPr wrap="none" rtlCol="0">
+            <a:spAutoFit/>
+          </a:bodyPr>
+          <a:lstStyle/>
+          <a:p>
+            <a:r>
+              <a:rPr lang="en-US" sz="2800" dirty="0"/>
+              <a:t>5.</a:t>
+            </a:r>
+          </a:p>
+        </p:txBody>
+      </p:sp>
+      <p:sp>
+        <p:nvSpPr>
+          <p:cNvPr id="32" name="Oval 31">
+            <a:extLst>
+              <a:ext uri="{FF2B5EF4-FFF2-40B4-BE49-F238E27FC236}">
+                <a16:creationId xmlns:a16="http://schemas.microsoft.com/office/drawing/2014/main" id="{D95260B2-8FEF-AEFB-0472-E885559A7F2A}"/>
+              </a:ext>
+            </a:extLst>
+          </p:cNvPr>
+          <p:cNvSpPr/>
+          <p:nvPr/>
+        </p:nvSpPr>
+        <p:spPr>
+          <a:xfrm>
+            <a:off x="4332289" y="1442074"/>
+            <a:ext cx="466928" cy="466928"/>
+          </a:xfrm>
+          <a:prstGeom prst="ellipse">
+            <a:avLst/>
+          </a:prstGeom>
+          <a:solidFill>
+            <a:schemeClr val="accent1">
+              <a:lumMod val="40000"/>
+              <a:lumOff val="60000"/>
+            </a:schemeClr>
+          </a:solidFill>
+          <a:ln w="38100"/>
+        </p:spPr>
+        <p:style>
+          <a:lnRef idx="2">
+            <a:schemeClr val="accent1">
+              <a:shade val="15000"/>
+            </a:schemeClr>
+          </a:lnRef>
+          <a:fillRef idx="1">
+            <a:schemeClr val="accent1"/>
+          </a:fillRef>
+          <a:effectRef idx="0">
+            <a:schemeClr val="accent1"/>
+          </a:effectRef>
+          <a:fontRef idx="minor">
+            <a:schemeClr val="lt1"/>
+          </a:fontRef>
+        </p:style>
+        <p:txBody>
+          <a:bodyPr rtlCol="0" anchor="ctr"/>
+          <a:lstStyle/>
+          <a:p>
+            <a:pPr algn="ctr"/>
+            <a:endParaRPr lang="en-US"/>
+          </a:p>
+        </p:txBody>
+      </p:sp>
+      <p:sp>
+        <p:nvSpPr>
+          <p:cNvPr id="33" name="Oval 32">
+            <a:extLst>
+              <a:ext uri="{FF2B5EF4-FFF2-40B4-BE49-F238E27FC236}">
+                <a16:creationId xmlns:a16="http://schemas.microsoft.com/office/drawing/2014/main" id="{239AB095-4D15-0135-F0D6-FBAD6B5930A8}"/>
+              </a:ext>
+            </a:extLst>
+          </p:cNvPr>
+          <p:cNvSpPr/>
+          <p:nvPr/>
+        </p:nvSpPr>
+        <p:spPr>
+          <a:xfrm>
+            <a:off x="4919018" y="1442074"/>
+            <a:ext cx="466928" cy="466928"/>
+          </a:xfrm>
+          <a:prstGeom prst="ellipse">
+            <a:avLst/>
+          </a:prstGeom>
+          <a:solidFill>
+            <a:schemeClr val="accent3">
+              <a:lumMod val="40000"/>
+              <a:lumOff val="60000"/>
+            </a:schemeClr>
+          </a:solidFill>
+          <a:ln w="38100"/>
+        </p:spPr>
+        <p:style>
+          <a:lnRef idx="2">
+            <a:schemeClr val="accent1">
+              <a:shade val="15000"/>
+            </a:schemeClr>
+          </a:lnRef>
+          <a:fillRef idx="1">
+            <a:schemeClr val="accent1"/>
+          </a:fillRef>
+          <a:effectRef idx="0">
+            <a:schemeClr val="accent1"/>
+          </a:effectRef>
+          <a:fontRef idx="minor">
+            <a:schemeClr val="lt1"/>
+          </a:fontRef>
+        </p:style>
+        <p:txBody>
+          <a:bodyPr rtlCol="0" anchor="ctr"/>
+          <a:lstStyle/>
+          <a:p>
+            <a:pPr algn="ctr"/>
+            <a:endParaRPr lang="en-US"/>
+          </a:p>
+        </p:txBody>
+      </p:sp>
+      <p:sp>
+        <p:nvSpPr>
+          <p:cNvPr id="34" name="Oval 33">
+            <a:extLst>
+              <a:ext uri="{FF2B5EF4-FFF2-40B4-BE49-F238E27FC236}">
+                <a16:creationId xmlns:a16="http://schemas.microsoft.com/office/drawing/2014/main" id="{C5E4FC44-2C50-F0AC-6DB6-2C852ABC5F64}"/>
+              </a:ext>
+            </a:extLst>
+          </p:cNvPr>
+          <p:cNvSpPr/>
+          <p:nvPr/>
+        </p:nvSpPr>
+        <p:spPr>
+          <a:xfrm>
+            <a:off x="3740413" y="1442074"/>
+            <a:ext cx="466928" cy="466928"/>
+          </a:xfrm>
+          <a:prstGeom prst="ellipse">
+            <a:avLst/>
+          </a:prstGeom>
+          <a:solidFill>
+            <a:schemeClr val="accent3">
+              <a:lumMod val="40000"/>
+              <a:lumOff val="60000"/>
+            </a:schemeClr>
+          </a:solidFill>
+          <a:ln w="38100"/>
+        </p:spPr>
+        <p:style>
+          <a:lnRef idx="2">
+            <a:schemeClr val="accent1">
+              <a:shade val="15000"/>
+            </a:schemeClr>
+          </a:lnRef>
+          <a:fillRef idx="1">
+            <a:schemeClr val="accent1"/>
+          </a:fillRef>
+          <a:effectRef idx="0">
+            <a:schemeClr val="accent1"/>
+          </a:effectRef>
+          <a:fontRef idx="minor">
+            <a:schemeClr val="lt1"/>
+          </a:fontRef>
+        </p:style>
+        <p:txBody>
+          <a:bodyPr rtlCol="0" anchor="ctr"/>
+          <a:lstStyle/>
+          <a:p>
+            <a:pPr algn="ctr"/>
+            <a:endParaRPr lang="en-US"/>
+          </a:p>
+        </p:txBody>
+      </p:sp>
+      <p:sp>
+        <p:nvSpPr>
+          <p:cNvPr id="65" name="TextBox 64">
+            <a:extLst>
+              <a:ext uri="{FF2B5EF4-FFF2-40B4-BE49-F238E27FC236}">
+                <a16:creationId xmlns:a16="http://schemas.microsoft.com/office/drawing/2014/main" id="{5F06A867-A6A4-0800-8BC7-D99AF59A0C53}"/>
+              </a:ext>
+            </a:extLst>
+          </p:cNvPr>
+          <p:cNvSpPr txBox="1"/>
+          <p:nvPr/>
+        </p:nvSpPr>
+        <p:spPr>
+          <a:xfrm>
+            <a:off x="4724090" y="2570176"/>
+            <a:ext cx="505267" cy="523220"/>
+          </a:xfrm>
+          <a:prstGeom prst="rect">
+            <a:avLst/>
+          </a:prstGeom>
+          <a:noFill/>
+        </p:spPr>
+        <p:txBody>
+          <a:bodyPr wrap="none" rtlCol="0">
+            <a:spAutoFit/>
+          </a:bodyPr>
+          <a:lstStyle/>
+          <a:p>
+            <a:r>
+              <a:rPr lang="en-US" sz="2800" dirty="0"/>
+              <a:t>4</a:t>
+            </a:r>
+            <a:r>
+              <a:rPr lang="en-US" sz="2800" baseline="30000" dirty="0"/>
+              <a:t>4</a:t>
+            </a:r>
+          </a:p>
+        </p:txBody>
+      </p:sp>
+      <p:sp>
+        <p:nvSpPr>
+          <p:cNvPr id="66" name="TextBox 65">
+            <a:extLst>
+              <a:ext uri="{FF2B5EF4-FFF2-40B4-BE49-F238E27FC236}">
+                <a16:creationId xmlns:a16="http://schemas.microsoft.com/office/drawing/2014/main" id="{FD520CE3-26B5-5917-2582-0D9394B8CFEF}"/>
+              </a:ext>
+            </a:extLst>
+          </p:cNvPr>
+          <p:cNvSpPr txBox="1"/>
+          <p:nvPr/>
+        </p:nvSpPr>
+        <p:spPr>
+          <a:xfrm>
+            <a:off x="4724090" y="5242040"/>
+            <a:ext cx="505267" cy="523220"/>
+          </a:xfrm>
+          <a:prstGeom prst="rect">
+            <a:avLst/>
+          </a:prstGeom>
+          <a:noFill/>
+        </p:spPr>
+        <p:txBody>
+          <a:bodyPr wrap="none" rtlCol="0">
+            <a:spAutoFit/>
+          </a:bodyPr>
+          <a:lstStyle/>
+          <a:p>
+            <a:r>
+              <a:rPr lang="en-US" sz="2800" dirty="0"/>
+              <a:t>0</a:t>
+            </a:r>
+            <a:r>
+              <a:rPr lang="en-US" sz="2800" baseline="30000" dirty="0"/>
+              <a:t>4</a:t>
+            </a:r>
+          </a:p>
+        </p:txBody>
+      </p:sp>
+      <p:sp>
+        <p:nvSpPr>
+          <p:cNvPr id="67" name="TextBox 66">
+            <a:extLst>
+              <a:ext uri="{FF2B5EF4-FFF2-40B4-BE49-F238E27FC236}">
+                <a16:creationId xmlns:a16="http://schemas.microsoft.com/office/drawing/2014/main" id="{9B3DC2B8-84C1-953A-3229-7D762E1C49D2}"/>
+              </a:ext>
+            </a:extLst>
+          </p:cNvPr>
+          <p:cNvSpPr txBox="1"/>
+          <p:nvPr/>
+        </p:nvSpPr>
+        <p:spPr>
+          <a:xfrm>
+            <a:off x="4724090" y="3238142"/>
+            <a:ext cx="505267" cy="523220"/>
+          </a:xfrm>
+          <a:prstGeom prst="rect">
+            <a:avLst/>
+          </a:prstGeom>
+          <a:noFill/>
+        </p:spPr>
+        <p:txBody>
+          <a:bodyPr wrap="none" rtlCol="0">
+            <a:spAutoFit/>
+          </a:bodyPr>
+          <a:lstStyle/>
+          <a:p>
+            <a:r>
+              <a:rPr lang="en-US" sz="2800" dirty="0"/>
+              <a:t>3</a:t>
+            </a:r>
+            <a:r>
+              <a:rPr lang="en-US" sz="2800" baseline="30000" dirty="0"/>
+              <a:t>4</a:t>
+            </a:r>
+          </a:p>
+        </p:txBody>
+      </p:sp>
+      <p:sp>
+        <p:nvSpPr>
+          <p:cNvPr id="68" name="TextBox 67">
+            <a:extLst>
+              <a:ext uri="{FF2B5EF4-FFF2-40B4-BE49-F238E27FC236}">
+                <a16:creationId xmlns:a16="http://schemas.microsoft.com/office/drawing/2014/main" id="{8612C908-1C81-89ED-8041-F326BE829003}"/>
+              </a:ext>
+            </a:extLst>
+          </p:cNvPr>
+          <p:cNvSpPr txBox="1"/>
+          <p:nvPr/>
+        </p:nvSpPr>
+        <p:spPr>
+          <a:xfrm>
+            <a:off x="4724090" y="4602220"/>
+            <a:ext cx="505267" cy="523220"/>
+          </a:xfrm>
+          <a:prstGeom prst="rect">
+            <a:avLst/>
+          </a:prstGeom>
+          <a:noFill/>
+        </p:spPr>
+        <p:txBody>
+          <a:bodyPr wrap="none" rtlCol="0">
+            <a:spAutoFit/>
+          </a:bodyPr>
+          <a:lstStyle/>
+          <a:p>
+            <a:r>
+              <a:rPr lang="en-US" sz="2800" dirty="0"/>
+              <a:t>1</a:t>
+            </a:r>
+            <a:r>
+              <a:rPr lang="en-US" sz="2800" baseline="30000" dirty="0"/>
+              <a:t>4</a:t>
+            </a:r>
+          </a:p>
+        </p:txBody>
+      </p:sp>
+      <p:sp>
+        <p:nvSpPr>
+          <p:cNvPr id="69" name="TextBox 68">
+            <a:extLst>
+              <a:ext uri="{FF2B5EF4-FFF2-40B4-BE49-F238E27FC236}">
+                <a16:creationId xmlns:a16="http://schemas.microsoft.com/office/drawing/2014/main" id="{3B7CFD97-2100-BEBD-9963-F4E0EE1B9C9D}"/>
+              </a:ext>
+            </a:extLst>
+          </p:cNvPr>
+          <p:cNvSpPr txBox="1"/>
+          <p:nvPr/>
+        </p:nvSpPr>
+        <p:spPr>
+          <a:xfrm>
+            <a:off x="4724090" y="3934254"/>
+            <a:ext cx="505267" cy="523220"/>
+          </a:xfrm>
+          <a:prstGeom prst="rect">
+            <a:avLst/>
+          </a:prstGeom>
+          <a:noFill/>
+        </p:spPr>
+        <p:txBody>
+          <a:bodyPr wrap="none" rtlCol="0">
+            <a:spAutoFit/>
+          </a:bodyPr>
+          <a:lstStyle/>
+          <a:p>
+            <a:r>
+              <a:rPr lang="en-US" sz="2800" dirty="0"/>
+              <a:t>2</a:t>
+            </a:r>
+            <a:r>
+              <a:rPr lang="en-US" sz="2800" baseline="30000" dirty="0"/>
+              <a:t>4</a:t>
+            </a:r>
+          </a:p>
+        </p:txBody>
+      </p:sp>
+      <p:sp>
+        <p:nvSpPr>
+          <p:cNvPr id="23" name="Oval 22">
+            <a:extLst>
+              <a:ext uri="{FF2B5EF4-FFF2-40B4-BE49-F238E27FC236}">
+                <a16:creationId xmlns:a16="http://schemas.microsoft.com/office/drawing/2014/main" id="{282C37A4-1FBF-51F6-AAFA-526AA01FC887}"/>
+              </a:ext>
+            </a:extLst>
+          </p:cNvPr>
+          <p:cNvSpPr/>
+          <p:nvPr/>
+        </p:nvSpPr>
+        <p:spPr>
+          <a:xfrm>
+            <a:off x="5527138" y="1442074"/>
+            <a:ext cx="466928" cy="466928"/>
+          </a:xfrm>
+          <a:prstGeom prst="ellipse">
+            <a:avLst/>
+          </a:prstGeom>
+          <a:solidFill>
+            <a:schemeClr val="accent3">
+              <a:lumMod val="40000"/>
+              <a:lumOff val="60000"/>
+            </a:schemeClr>
+          </a:solidFill>
+          <a:ln w="38100"/>
+        </p:spPr>
+        <p:style>
+          <a:lnRef idx="2">
+            <a:schemeClr val="accent1">
+              <a:shade val="15000"/>
+            </a:schemeClr>
+          </a:lnRef>
+          <a:fillRef idx="1">
+            <a:schemeClr val="accent1"/>
+          </a:fillRef>
+          <a:effectRef idx="0">
+            <a:schemeClr val="accent1"/>
+          </a:effectRef>
+          <a:fontRef idx="minor">
+            <a:schemeClr val="lt1"/>
+          </a:fontRef>
+        </p:style>
+        <p:txBody>
+          <a:bodyPr rtlCol="0" anchor="ctr"/>
+          <a:lstStyle/>
+          <a:p>
+            <a:pPr algn="ctr"/>
+            <a:endParaRPr lang="en-US"/>
+          </a:p>
+        </p:txBody>
+      </p:sp>
+      <p:sp>
+        <p:nvSpPr>
+          <p:cNvPr id="76" name="Oval 75">
+            <a:extLst>
+              <a:ext uri="{FF2B5EF4-FFF2-40B4-BE49-F238E27FC236}">
+                <a16:creationId xmlns:a16="http://schemas.microsoft.com/office/drawing/2014/main" id="{1EA3B7C9-49B0-39E6-7B50-C247B97974E6}"/>
+              </a:ext>
+            </a:extLst>
+          </p:cNvPr>
+          <p:cNvSpPr/>
+          <p:nvPr/>
+        </p:nvSpPr>
+        <p:spPr>
+          <a:xfrm>
+            <a:off x="6096000" y="1442074"/>
+            <a:ext cx="466928" cy="466928"/>
+          </a:xfrm>
+          <a:prstGeom prst="ellipse">
+            <a:avLst/>
+          </a:prstGeom>
+          <a:solidFill>
+            <a:schemeClr val="accent1">
+              <a:lumMod val="40000"/>
+              <a:lumOff val="60000"/>
+            </a:schemeClr>
+          </a:solidFill>
+          <a:ln w="38100"/>
+        </p:spPr>
+        <p:style>
+          <a:lnRef idx="2">
+            <a:schemeClr val="accent1">
+              <a:shade val="15000"/>
+            </a:schemeClr>
+          </a:lnRef>
+          <a:fillRef idx="1">
+            <a:schemeClr val="accent1"/>
+          </a:fillRef>
+          <a:effectRef idx="0">
+            <a:schemeClr val="accent1"/>
+          </a:effectRef>
+          <a:fontRef idx="minor">
+            <a:schemeClr val="lt1"/>
+          </a:fontRef>
+        </p:style>
+        <p:txBody>
+          <a:bodyPr rtlCol="0" anchor="ctr"/>
+          <a:lstStyle/>
+          <a:p>
+            <a:pPr algn="ctr"/>
+            <a:endParaRPr lang="en-US"/>
+          </a:p>
+        </p:txBody>
+      </p:sp>
+      <p:sp>
+        <p:nvSpPr>
+          <p:cNvPr id="87" name="Oval 86">
+            <a:extLst>
+              <a:ext uri="{FF2B5EF4-FFF2-40B4-BE49-F238E27FC236}">
+                <a16:creationId xmlns:a16="http://schemas.microsoft.com/office/drawing/2014/main" id="{0260A189-D743-28C3-F4FE-1D43EC6E6352}"/>
+              </a:ext>
+            </a:extLst>
+          </p:cNvPr>
+          <p:cNvSpPr/>
+          <p:nvPr/>
+        </p:nvSpPr>
+        <p:spPr>
+          <a:xfrm>
+            <a:off x="6673377" y="1442074"/>
+            <a:ext cx="466928" cy="466928"/>
+          </a:xfrm>
+          <a:prstGeom prst="ellipse">
+            <a:avLst/>
+          </a:prstGeom>
+          <a:solidFill>
+            <a:schemeClr val="accent1">
+              <a:lumMod val="40000"/>
+              <a:lumOff val="60000"/>
+            </a:schemeClr>
+          </a:solidFill>
+          <a:ln w="38100"/>
+        </p:spPr>
+        <p:style>
+          <a:lnRef idx="2">
+            <a:schemeClr val="accent1">
+              <a:shade val="15000"/>
+            </a:schemeClr>
+          </a:lnRef>
+          <a:fillRef idx="1">
+            <a:schemeClr val="accent1"/>
+          </a:fillRef>
+          <a:effectRef idx="0">
+            <a:schemeClr val="accent1"/>
+          </a:effectRef>
+          <a:fontRef idx="minor">
+            <a:schemeClr val="lt1"/>
+          </a:fontRef>
+        </p:style>
+        <p:txBody>
+          <a:bodyPr rtlCol="0" anchor="ctr"/>
+          <a:lstStyle/>
+          <a:p>
+            <a:pPr algn="ctr"/>
+            <a:endParaRPr lang="en-US"/>
+          </a:p>
+        </p:txBody>
+      </p:sp>
+      <p:sp>
+        <p:nvSpPr>
+          <p:cNvPr id="98" name="Oval 97">
+            <a:extLst>
+              <a:ext uri="{FF2B5EF4-FFF2-40B4-BE49-F238E27FC236}">
+                <a16:creationId xmlns:a16="http://schemas.microsoft.com/office/drawing/2014/main" id="{FA6BCE77-0594-C1EC-8917-C95D81E9E3D5}"/>
+              </a:ext>
+            </a:extLst>
+          </p:cNvPr>
+          <p:cNvSpPr/>
+          <p:nvPr/>
+        </p:nvSpPr>
+        <p:spPr>
+          <a:xfrm>
+            <a:off x="7226751" y="1442074"/>
+            <a:ext cx="466928" cy="466928"/>
+          </a:xfrm>
+          <a:prstGeom prst="ellipse">
+            <a:avLst/>
+          </a:prstGeom>
+          <a:solidFill>
+            <a:schemeClr val="accent1">
+              <a:lumMod val="40000"/>
+              <a:lumOff val="60000"/>
+            </a:schemeClr>
+          </a:solidFill>
+          <a:ln w="38100"/>
+        </p:spPr>
+        <p:style>
+          <a:lnRef idx="2">
+            <a:schemeClr val="accent1">
+              <a:shade val="15000"/>
+            </a:schemeClr>
+          </a:lnRef>
+          <a:fillRef idx="1">
+            <a:schemeClr val="accent1"/>
+          </a:fillRef>
+          <a:effectRef idx="0">
+            <a:schemeClr val="accent1"/>
+          </a:effectRef>
+          <a:fontRef idx="minor">
+            <a:schemeClr val="lt1"/>
+          </a:fontRef>
+        </p:style>
+        <p:txBody>
+          <a:bodyPr rtlCol="0" anchor="ctr"/>
+          <a:lstStyle/>
+          <a:p>
+            <a:pPr algn="ctr"/>
+            <a:endParaRPr lang="en-US"/>
+          </a:p>
+        </p:txBody>
+      </p:sp>
+      <p:sp>
+        <p:nvSpPr>
+          <p:cNvPr id="109" name="Oval 108">
+            <a:extLst>
+              <a:ext uri="{FF2B5EF4-FFF2-40B4-BE49-F238E27FC236}">
+                <a16:creationId xmlns:a16="http://schemas.microsoft.com/office/drawing/2014/main" id="{80CD89FD-E61D-9677-9AC8-65B52315A401}"/>
+              </a:ext>
+            </a:extLst>
+          </p:cNvPr>
+          <p:cNvSpPr/>
+          <p:nvPr/>
+        </p:nvSpPr>
+        <p:spPr>
+          <a:xfrm>
+            <a:off x="7783769" y="1442074"/>
+            <a:ext cx="466928" cy="466928"/>
+          </a:xfrm>
+          <a:prstGeom prst="ellipse">
+            <a:avLst/>
+          </a:prstGeom>
+          <a:solidFill>
+            <a:schemeClr val="accent3">
+              <a:lumMod val="40000"/>
+              <a:lumOff val="60000"/>
+            </a:schemeClr>
+          </a:solidFill>
+          <a:ln w="38100"/>
+        </p:spPr>
+        <p:style>
+          <a:lnRef idx="2">
+            <a:schemeClr val="accent1">
+              <a:shade val="15000"/>
+            </a:schemeClr>
+          </a:lnRef>
+          <a:fillRef idx="1">
+            <a:schemeClr val="accent1"/>
+          </a:fillRef>
+          <a:effectRef idx="0">
+            <a:schemeClr val="accent1"/>
+          </a:effectRef>
+          <a:fontRef idx="minor">
+            <a:schemeClr val="lt1"/>
+          </a:fontRef>
+        </p:style>
+        <p:txBody>
+          <a:bodyPr rtlCol="0" anchor="ctr"/>
+          <a:lstStyle/>
+          <a:p>
+            <a:pPr algn="ctr"/>
+            <a:endParaRPr lang="en-US"/>
+          </a:p>
+        </p:txBody>
+      </p:sp>
+      <p:sp>
+        <p:nvSpPr>
+          <p:cNvPr id="120" name="Oval 119">
+            <a:extLst>
+              <a:ext uri="{FF2B5EF4-FFF2-40B4-BE49-F238E27FC236}">
+                <a16:creationId xmlns:a16="http://schemas.microsoft.com/office/drawing/2014/main" id="{CEC8D566-8095-B794-4B87-445F10A4A293}"/>
+              </a:ext>
+            </a:extLst>
+          </p:cNvPr>
+          <p:cNvSpPr/>
+          <p:nvPr/>
+        </p:nvSpPr>
+        <p:spPr>
+          <a:xfrm>
+            <a:off x="8331837" y="1442074"/>
+            <a:ext cx="466928" cy="466928"/>
+          </a:xfrm>
+          <a:prstGeom prst="ellipse">
+            <a:avLst/>
+          </a:prstGeom>
+          <a:solidFill>
+            <a:schemeClr val="accent1">
+              <a:lumMod val="40000"/>
+              <a:lumOff val="60000"/>
+            </a:schemeClr>
+          </a:solidFill>
+          <a:ln w="38100"/>
+        </p:spPr>
+        <p:style>
+          <a:lnRef idx="2">
+            <a:schemeClr val="accent1">
+              <a:shade val="15000"/>
+            </a:schemeClr>
+          </a:lnRef>
+          <a:fillRef idx="1">
+            <a:schemeClr val="accent1"/>
+          </a:fillRef>
+          <a:effectRef idx="0">
+            <a:schemeClr val="accent1"/>
+          </a:effectRef>
+          <a:fontRef idx="minor">
+            <a:schemeClr val="lt1"/>
+          </a:fontRef>
+        </p:style>
+        <p:txBody>
+          <a:bodyPr rtlCol="0" anchor="ctr"/>
+          <a:lstStyle/>
+          <a:p>
+            <a:pPr algn="ctr"/>
+            <a:endParaRPr lang="en-US"/>
+          </a:p>
+        </p:txBody>
+      </p:sp>
+      <p:sp>
+        <p:nvSpPr>
+          <p:cNvPr id="131" name="Oval 130">
+            <a:extLst>
+              <a:ext uri="{FF2B5EF4-FFF2-40B4-BE49-F238E27FC236}">
+                <a16:creationId xmlns:a16="http://schemas.microsoft.com/office/drawing/2014/main" id="{2A30DA0A-F243-04B5-80B9-E70457BA2FBF}"/>
+              </a:ext>
+            </a:extLst>
+          </p:cNvPr>
+          <p:cNvSpPr/>
+          <p:nvPr/>
+        </p:nvSpPr>
+        <p:spPr>
+          <a:xfrm>
+            <a:off x="8885211" y="1442074"/>
+            <a:ext cx="466928" cy="466928"/>
+          </a:xfrm>
+          <a:prstGeom prst="ellipse">
+            <a:avLst/>
+          </a:prstGeom>
+          <a:solidFill>
+            <a:schemeClr val="accent1">
+              <a:lumMod val="40000"/>
+              <a:lumOff val="60000"/>
+            </a:schemeClr>
+          </a:solidFill>
+          <a:ln w="38100"/>
+        </p:spPr>
+        <p:style>
+          <a:lnRef idx="2">
+            <a:schemeClr val="accent1">
+              <a:shade val="15000"/>
+            </a:schemeClr>
+          </a:lnRef>
+          <a:fillRef idx="1">
+            <a:schemeClr val="accent1"/>
+          </a:fillRef>
+          <a:effectRef idx="0">
+            <a:schemeClr val="accent1"/>
+          </a:effectRef>
+          <a:fontRef idx="minor">
+            <a:schemeClr val="lt1"/>
+          </a:fontRef>
+        </p:style>
+        <p:txBody>
+          <a:bodyPr rtlCol="0" anchor="ctr"/>
+          <a:lstStyle/>
+          <a:p>
+            <a:pPr algn="ctr"/>
+            <a:endParaRPr lang="en-US"/>
+          </a:p>
+        </p:txBody>
+      </p:sp>
+      <p:sp>
+        <p:nvSpPr>
+          <p:cNvPr id="142" name="TextBox 141">
+            <a:extLst>
+              <a:ext uri="{FF2B5EF4-FFF2-40B4-BE49-F238E27FC236}">
+                <a16:creationId xmlns:a16="http://schemas.microsoft.com/office/drawing/2014/main" id="{A5D40A96-93BC-121F-9289-D3FD4E446AB4}"/>
+              </a:ext>
+            </a:extLst>
+          </p:cNvPr>
+          <p:cNvSpPr txBox="1"/>
+          <p:nvPr/>
+        </p:nvSpPr>
+        <p:spPr>
+          <a:xfrm>
+            <a:off x="5204982" y="2647120"/>
+            <a:ext cx="287258" cy="369332"/>
+          </a:xfrm>
+          <a:prstGeom prst="rect">
+            <a:avLst/>
+          </a:prstGeom>
+          <a:noFill/>
+        </p:spPr>
+        <p:txBody>
+          <a:bodyPr wrap="none" rtlCol="0">
+            <a:spAutoFit/>
+          </a:bodyPr>
+          <a:lstStyle/>
+          <a:p>
+            <a:r>
+              <a:rPr lang="en-US" dirty="0"/>
+              <a:t>x</a:t>
+            </a:r>
+          </a:p>
+        </p:txBody>
+      </p:sp>
+      <p:sp>
+        <p:nvSpPr>
+          <p:cNvPr id="143" name="TextBox 142">
+            <a:extLst>
+              <a:ext uri="{FF2B5EF4-FFF2-40B4-BE49-F238E27FC236}">
+                <a16:creationId xmlns:a16="http://schemas.microsoft.com/office/drawing/2014/main" id="{9B395F72-35D2-8AEB-9888-2DA237FC4038}"/>
+              </a:ext>
+            </a:extLst>
+          </p:cNvPr>
+          <p:cNvSpPr txBox="1"/>
+          <p:nvPr/>
+        </p:nvSpPr>
+        <p:spPr>
+          <a:xfrm>
+            <a:off x="5204982" y="3998091"/>
+            <a:ext cx="287258" cy="369332"/>
+          </a:xfrm>
+          <a:prstGeom prst="rect">
+            <a:avLst/>
+          </a:prstGeom>
+          <a:noFill/>
+        </p:spPr>
+        <p:txBody>
+          <a:bodyPr wrap="none" rtlCol="0">
+            <a:spAutoFit/>
+          </a:bodyPr>
+          <a:lstStyle/>
+          <a:p>
+            <a:r>
+              <a:rPr lang="en-US" dirty="0"/>
+              <a:t>x</a:t>
+            </a:r>
+          </a:p>
+        </p:txBody>
+      </p:sp>
+      <p:sp>
+        <p:nvSpPr>
+          <p:cNvPr id="144" name="TextBox 143">
+            <a:extLst>
+              <a:ext uri="{FF2B5EF4-FFF2-40B4-BE49-F238E27FC236}">
+                <a16:creationId xmlns:a16="http://schemas.microsoft.com/office/drawing/2014/main" id="{1263979E-A8B3-A49A-F768-9BF17A21178A}"/>
+              </a:ext>
+            </a:extLst>
+          </p:cNvPr>
+          <p:cNvSpPr txBox="1"/>
+          <p:nvPr/>
+        </p:nvSpPr>
+        <p:spPr>
+          <a:xfrm>
+            <a:off x="5204982" y="3293732"/>
+            <a:ext cx="287258" cy="369332"/>
+          </a:xfrm>
+          <a:prstGeom prst="rect">
+            <a:avLst/>
+          </a:prstGeom>
+          <a:noFill/>
+        </p:spPr>
+        <p:txBody>
+          <a:bodyPr wrap="none" rtlCol="0">
+            <a:spAutoFit/>
+          </a:bodyPr>
+          <a:lstStyle/>
+          <a:p>
+            <a:r>
+              <a:rPr lang="en-US" dirty="0"/>
+              <a:t>x</a:t>
+            </a:r>
+          </a:p>
+        </p:txBody>
+      </p:sp>
+      <p:sp>
+        <p:nvSpPr>
+          <p:cNvPr id="145" name="TextBox 144">
+            <a:extLst>
+              <a:ext uri="{FF2B5EF4-FFF2-40B4-BE49-F238E27FC236}">
+                <a16:creationId xmlns:a16="http://schemas.microsoft.com/office/drawing/2014/main" id="{5C990CBD-9ABD-3FD2-F844-160C4FC40BBE}"/>
+              </a:ext>
+            </a:extLst>
+          </p:cNvPr>
+          <p:cNvSpPr txBox="1"/>
+          <p:nvPr/>
+        </p:nvSpPr>
+        <p:spPr>
+          <a:xfrm>
+            <a:off x="5204982" y="4703730"/>
+            <a:ext cx="287258" cy="369332"/>
+          </a:xfrm>
+          <a:prstGeom prst="rect">
+            <a:avLst/>
+          </a:prstGeom>
+          <a:noFill/>
+        </p:spPr>
+        <p:txBody>
+          <a:bodyPr wrap="none" rtlCol="0">
+            <a:spAutoFit/>
+          </a:bodyPr>
+          <a:lstStyle/>
+          <a:p>
+            <a:r>
+              <a:rPr lang="en-US" dirty="0"/>
+              <a:t>x</a:t>
+            </a:r>
+          </a:p>
+        </p:txBody>
+      </p:sp>
+      <p:sp>
+        <p:nvSpPr>
+          <p:cNvPr id="146" name="TextBox 145">
+            <a:extLst>
+              <a:ext uri="{FF2B5EF4-FFF2-40B4-BE49-F238E27FC236}">
+                <a16:creationId xmlns:a16="http://schemas.microsoft.com/office/drawing/2014/main" id="{72E899DC-E5A7-2352-68EF-F1C2E7E98695}"/>
+              </a:ext>
+            </a:extLst>
+          </p:cNvPr>
+          <p:cNvSpPr txBox="1"/>
+          <p:nvPr/>
+        </p:nvSpPr>
+        <p:spPr>
+          <a:xfrm>
+            <a:off x="5194491" y="5318984"/>
+            <a:ext cx="287258" cy="369332"/>
+          </a:xfrm>
+          <a:prstGeom prst="rect">
+            <a:avLst/>
+          </a:prstGeom>
+          <a:noFill/>
+        </p:spPr>
+        <p:txBody>
+          <a:bodyPr wrap="none" rtlCol="0">
+            <a:spAutoFit/>
+          </a:bodyPr>
+          <a:lstStyle/>
+          <a:p>
+            <a:r>
+              <a:rPr lang="en-US" dirty="0"/>
+              <a:t>x</a:t>
+            </a:r>
+          </a:p>
+        </p:txBody>
+      </p:sp>
+      <p:sp>
+        <p:nvSpPr>
+          <p:cNvPr id="147" name="TextBox 146">
+            <a:extLst>
+              <a:ext uri="{FF2B5EF4-FFF2-40B4-BE49-F238E27FC236}">
+                <a16:creationId xmlns:a16="http://schemas.microsoft.com/office/drawing/2014/main" id="{A1968FD0-327B-DB0A-5738-83D0088AF6E7}"/>
+              </a:ext>
+            </a:extLst>
+          </p:cNvPr>
+          <p:cNvSpPr txBox="1"/>
+          <p:nvPr/>
+        </p:nvSpPr>
+        <p:spPr>
+          <a:xfrm>
+            <a:off x="5387832" y="2570176"/>
+            <a:ext cx="505267" cy="523220"/>
+          </a:xfrm>
+          <a:prstGeom prst="rect">
+            <a:avLst/>
+          </a:prstGeom>
+          <a:noFill/>
+        </p:spPr>
+        <p:txBody>
+          <a:bodyPr wrap="none" rtlCol="0">
+            <a:spAutoFit/>
+          </a:bodyPr>
+          <a:lstStyle/>
+          <a:p>
+            <a:r>
+              <a:rPr lang="en-US" sz="2800" dirty="0"/>
+              <a:t>0</a:t>
+            </a:r>
+            <a:r>
+              <a:rPr lang="en-US" sz="2800" baseline="30000" dirty="0"/>
+              <a:t>6</a:t>
+            </a:r>
+          </a:p>
+        </p:txBody>
+      </p:sp>
+      <p:sp>
+        <p:nvSpPr>
+          <p:cNvPr id="148" name="TextBox 147">
+            <a:extLst>
+              <a:ext uri="{FF2B5EF4-FFF2-40B4-BE49-F238E27FC236}">
+                <a16:creationId xmlns:a16="http://schemas.microsoft.com/office/drawing/2014/main" id="{E9C9C354-1ABB-3AC6-5003-C99963874A61}"/>
+              </a:ext>
+            </a:extLst>
+          </p:cNvPr>
+          <p:cNvSpPr txBox="1"/>
+          <p:nvPr/>
+        </p:nvSpPr>
+        <p:spPr>
+          <a:xfrm>
+            <a:off x="5387832" y="5242040"/>
+            <a:ext cx="505267" cy="523220"/>
+          </a:xfrm>
+          <a:prstGeom prst="rect">
+            <a:avLst/>
+          </a:prstGeom>
+          <a:noFill/>
+        </p:spPr>
+        <p:txBody>
+          <a:bodyPr wrap="none" rtlCol="0">
+            <a:spAutoFit/>
+          </a:bodyPr>
+          <a:lstStyle/>
+          <a:p>
+            <a:r>
+              <a:rPr lang="en-US" sz="2800" dirty="0"/>
+              <a:t>4</a:t>
+            </a:r>
+            <a:r>
+              <a:rPr lang="en-US" sz="2800" baseline="30000" dirty="0"/>
+              <a:t>6</a:t>
+            </a:r>
+          </a:p>
+        </p:txBody>
+      </p:sp>
+      <p:sp>
+        <p:nvSpPr>
+          <p:cNvPr id="149" name="TextBox 148">
+            <a:extLst>
+              <a:ext uri="{FF2B5EF4-FFF2-40B4-BE49-F238E27FC236}">
+                <a16:creationId xmlns:a16="http://schemas.microsoft.com/office/drawing/2014/main" id="{456727E7-E5A4-4F64-2DF9-000CAD0D85A3}"/>
+              </a:ext>
+            </a:extLst>
+          </p:cNvPr>
+          <p:cNvSpPr txBox="1"/>
+          <p:nvPr/>
+        </p:nvSpPr>
+        <p:spPr>
+          <a:xfrm>
+            <a:off x="5387832" y="3238142"/>
+            <a:ext cx="505267" cy="523220"/>
+          </a:xfrm>
+          <a:prstGeom prst="rect">
+            <a:avLst/>
+          </a:prstGeom>
+          <a:noFill/>
+        </p:spPr>
+        <p:txBody>
+          <a:bodyPr wrap="none" rtlCol="0">
+            <a:spAutoFit/>
+          </a:bodyPr>
+          <a:lstStyle/>
+          <a:p>
+            <a:r>
+              <a:rPr lang="en-US" sz="2800" dirty="0"/>
+              <a:t>1</a:t>
+            </a:r>
+            <a:r>
+              <a:rPr lang="en-US" sz="2800" baseline="30000" dirty="0"/>
+              <a:t>6</a:t>
+            </a:r>
+          </a:p>
+        </p:txBody>
+      </p:sp>
+      <p:sp>
+        <p:nvSpPr>
+          <p:cNvPr id="150" name="TextBox 149">
+            <a:extLst>
+              <a:ext uri="{FF2B5EF4-FFF2-40B4-BE49-F238E27FC236}">
+                <a16:creationId xmlns:a16="http://schemas.microsoft.com/office/drawing/2014/main" id="{327AE54E-7CAB-92C8-8AE2-FA771C39D421}"/>
+              </a:ext>
+            </a:extLst>
+          </p:cNvPr>
+          <p:cNvSpPr txBox="1"/>
+          <p:nvPr/>
+        </p:nvSpPr>
+        <p:spPr>
+          <a:xfrm>
+            <a:off x="5387832" y="4602220"/>
+            <a:ext cx="505267" cy="523220"/>
+          </a:xfrm>
+          <a:prstGeom prst="rect">
+            <a:avLst/>
+          </a:prstGeom>
+          <a:noFill/>
+        </p:spPr>
+        <p:txBody>
+          <a:bodyPr wrap="none" rtlCol="0">
+            <a:spAutoFit/>
+          </a:bodyPr>
+          <a:lstStyle/>
+          <a:p>
+            <a:r>
+              <a:rPr lang="en-US" sz="2800" dirty="0"/>
+              <a:t>3</a:t>
+            </a:r>
+            <a:r>
+              <a:rPr lang="en-US" sz="2800" baseline="30000" dirty="0"/>
+              <a:t>6</a:t>
+            </a:r>
+          </a:p>
+        </p:txBody>
+      </p:sp>
+      <p:sp>
+        <p:nvSpPr>
+          <p:cNvPr id="151" name="TextBox 150">
+            <a:extLst>
+              <a:ext uri="{FF2B5EF4-FFF2-40B4-BE49-F238E27FC236}">
+                <a16:creationId xmlns:a16="http://schemas.microsoft.com/office/drawing/2014/main" id="{2F2F43BE-6B82-53BE-B22E-61DB29F2338F}"/>
+              </a:ext>
+            </a:extLst>
+          </p:cNvPr>
+          <p:cNvSpPr txBox="1"/>
+          <p:nvPr/>
+        </p:nvSpPr>
+        <p:spPr>
+          <a:xfrm>
+            <a:off x="5387832" y="3934254"/>
+            <a:ext cx="505267" cy="523220"/>
+          </a:xfrm>
+          <a:prstGeom prst="rect">
+            <a:avLst/>
+          </a:prstGeom>
+          <a:noFill/>
+        </p:spPr>
+        <p:txBody>
+          <a:bodyPr wrap="none" rtlCol="0">
+            <a:spAutoFit/>
+          </a:bodyPr>
+          <a:lstStyle/>
+          <a:p>
+            <a:r>
+              <a:rPr lang="en-US" sz="2800" dirty="0"/>
+              <a:t>2</a:t>
+            </a:r>
+            <a:r>
+              <a:rPr lang="en-US" sz="2800" baseline="30000" dirty="0"/>
+              <a:t>6</a:t>
+            </a:r>
+          </a:p>
+        </p:txBody>
+      </p:sp>
+      <p:sp>
+        <p:nvSpPr>
+          <p:cNvPr id="157" name="TextBox 156">
+            <a:extLst>
+              <a:ext uri="{FF2B5EF4-FFF2-40B4-BE49-F238E27FC236}">
+                <a16:creationId xmlns:a16="http://schemas.microsoft.com/office/drawing/2014/main" id="{32E07426-2F3A-2DAF-E602-1555DDDBA715}"/>
+              </a:ext>
+            </a:extLst>
+          </p:cNvPr>
+          <p:cNvSpPr txBox="1"/>
+          <p:nvPr/>
+        </p:nvSpPr>
+        <p:spPr>
+          <a:xfrm>
+            <a:off x="5913678" y="2647120"/>
+            <a:ext cx="308098" cy="369332"/>
+          </a:xfrm>
+          <a:prstGeom prst="rect">
+            <a:avLst/>
+          </a:prstGeom>
+          <a:noFill/>
+        </p:spPr>
+        <p:txBody>
+          <a:bodyPr wrap="none" rtlCol="0">
+            <a:spAutoFit/>
+          </a:bodyPr>
+          <a:lstStyle/>
+          <a:p>
+            <a:r>
+              <a:rPr lang="en-US" dirty="0"/>
+              <a:t>=</a:t>
+            </a:r>
+          </a:p>
+        </p:txBody>
+      </p:sp>
+      <p:sp>
+        <p:nvSpPr>
+          <p:cNvPr id="158" name="TextBox 157">
+            <a:extLst>
+              <a:ext uri="{FF2B5EF4-FFF2-40B4-BE49-F238E27FC236}">
+                <a16:creationId xmlns:a16="http://schemas.microsoft.com/office/drawing/2014/main" id="{54BED28E-7BB3-CE32-96A4-E03646617130}"/>
+              </a:ext>
+            </a:extLst>
+          </p:cNvPr>
+          <p:cNvSpPr txBox="1"/>
+          <p:nvPr/>
+        </p:nvSpPr>
+        <p:spPr>
+          <a:xfrm>
+            <a:off x="5913678" y="3335738"/>
+            <a:ext cx="308098" cy="369332"/>
+          </a:xfrm>
+          <a:prstGeom prst="rect">
+            <a:avLst/>
+          </a:prstGeom>
+          <a:noFill/>
+        </p:spPr>
+        <p:txBody>
+          <a:bodyPr wrap="none" rtlCol="0">
+            <a:spAutoFit/>
+          </a:bodyPr>
+          <a:lstStyle/>
+          <a:p>
+            <a:r>
+              <a:rPr lang="en-US" dirty="0"/>
+              <a:t>=</a:t>
+            </a:r>
+          </a:p>
+        </p:txBody>
+      </p:sp>
+      <p:sp>
+        <p:nvSpPr>
+          <p:cNvPr id="159" name="TextBox 158">
+            <a:extLst>
+              <a:ext uri="{FF2B5EF4-FFF2-40B4-BE49-F238E27FC236}">
+                <a16:creationId xmlns:a16="http://schemas.microsoft.com/office/drawing/2014/main" id="{8337C3B8-5570-3415-8F1E-762A97E42969}"/>
+              </a:ext>
+            </a:extLst>
+          </p:cNvPr>
+          <p:cNvSpPr txBox="1"/>
+          <p:nvPr/>
+        </p:nvSpPr>
+        <p:spPr>
+          <a:xfrm>
+            <a:off x="5919571" y="4024356"/>
+            <a:ext cx="308098" cy="369332"/>
+          </a:xfrm>
+          <a:prstGeom prst="rect">
+            <a:avLst/>
+          </a:prstGeom>
+          <a:noFill/>
+        </p:spPr>
+        <p:txBody>
+          <a:bodyPr wrap="none" rtlCol="0">
+            <a:spAutoFit/>
+          </a:bodyPr>
+          <a:lstStyle/>
+          <a:p>
+            <a:r>
+              <a:rPr lang="en-US" dirty="0"/>
+              <a:t>=</a:t>
+            </a:r>
+          </a:p>
+        </p:txBody>
+      </p:sp>
+      <p:sp>
+        <p:nvSpPr>
+          <p:cNvPr id="160" name="TextBox 159">
+            <a:extLst>
+              <a:ext uri="{FF2B5EF4-FFF2-40B4-BE49-F238E27FC236}">
+                <a16:creationId xmlns:a16="http://schemas.microsoft.com/office/drawing/2014/main" id="{8441855D-7ECD-5D42-4D39-F44E48EB6991}"/>
+              </a:ext>
+            </a:extLst>
+          </p:cNvPr>
+          <p:cNvSpPr txBox="1"/>
+          <p:nvPr/>
+        </p:nvSpPr>
+        <p:spPr>
+          <a:xfrm>
+            <a:off x="5919571" y="4699816"/>
+            <a:ext cx="308098" cy="369332"/>
+          </a:xfrm>
+          <a:prstGeom prst="rect">
+            <a:avLst/>
+          </a:prstGeom>
+          <a:noFill/>
+        </p:spPr>
+        <p:txBody>
+          <a:bodyPr wrap="none" rtlCol="0">
+            <a:spAutoFit/>
+          </a:bodyPr>
+          <a:lstStyle/>
+          <a:p>
+            <a:r>
+              <a:rPr lang="en-US" dirty="0"/>
+              <a:t>=</a:t>
+            </a:r>
+          </a:p>
+        </p:txBody>
+      </p:sp>
+      <p:sp>
+        <p:nvSpPr>
+          <p:cNvPr id="161" name="TextBox 160">
+            <a:extLst>
+              <a:ext uri="{FF2B5EF4-FFF2-40B4-BE49-F238E27FC236}">
+                <a16:creationId xmlns:a16="http://schemas.microsoft.com/office/drawing/2014/main" id="{9430556D-EA4A-208D-BD24-13D5F1AD28CA}"/>
+              </a:ext>
+            </a:extLst>
+          </p:cNvPr>
+          <p:cNvSpPr txBox="1"/>
+          <p:nvPr/>
+        </p:nvSpPr>
+        <p:spPr>
+          <a:xfrm>
+            <a:off x="5912029" y="5318984"/>
+            <a:ext cx="308098" cy="369332"/>
+          </a:xfrm>
+          <a:prstGeom prst="rect">
+            <a:avLst/>
+          </a:prstGeom>
+          <a:noFill/>
+        </p:spPr>
+        <p:txBody>
+          <a:bodyPr wrap="none" rtlCol="0">
+            <a:spAutoFit/>
+          </a:bodyPr>
+          <a:lstStyle/>
+          <a:p>
+            <a:r>
+              <a:rPr lang="en-US" dirty="0"/>
+              <a:t>=</a:t>
+            </a:r>
+          </a:p>
+        </p:txBody>
+      </p:sp>
+      <p:sp>
+        <p:nvSpPr>
+          <p:cNvPr id="162" name="TextBox 161">
+            <a:extLst>
+              <a:ext uri="{FF2B5EF4-FFF2-40B4-BE49-F238E27FC236}">
+                <a16:creationId xmlns:a16="http://schemas.microsoft.com/office/drawing/2014/main" id="{3C9A00F2-8B54-2B53-2E2C-662886F1406F}"/>
+              </a:ext>
+            </a:extLst>
+          </p:cNvPr>
+          <p:cNvSpPr txBox="1"/>
+          <p:nvPr/>
+        </p:nvSpPr>
+        <p:spPr>
+          <a:xfrm>
+            <a:off x="6272644" y="5242040"/>
+            <a:ext cx="377026" cy="523220"/>
+          </a:xfrm>
+          <a:prstGeom prst="rect">
+            <a:avLst/>
+          </a:prstGeom>
+          <a:noFill/>
+        </p:spPr>
+        <p:txBody>
+          <a:bodyPr wrap="none" rtlCol="0">
+            <a:spAutoFit/>
+          </a:bodyPr>
+          <a:lstStyle/>
+          <a:p>
+            <a:r>
+              <a:rPr lang="en-US" sz="2800" dirty="0"/>
+              <a:t>0</a:t>
+            </a:r>
+          </a:p>
+        </p:txBody>
+      </p:sp>
+      <p:sp>
+        <p:nvSpPr>
+          <p:cNvPr id="163" name="TextBox 162">
+            <a:extLst>
+              <a:ext uri="{FF2B5EF4-FFF2-40B4-BE49-F238E27FC236}">
+                <a16:creationId xmlns:a16="http://schemas.microsoft.com/office/drawing/2014/main" id="{0B4E7E54-FC9C-6F31-AE95-A353C1E41CE4}"/>
+              </a:ext>
+            </a:extLst>
+          </p:cNvPr>
+          <p:cNvSpPr txBox="1"/>
+          <p:nvPr/>
+        </p:nvSpPr>
+        <p:spPr>
+          <a:xfrm>
+            <a:off x="6272644" y="2570176"/>
+            <a:ext cx="377026" cy="523220"/>
+          </a:xfrm>
+          <a:prstGeom prst="rect">
+            <a:avLst/>
+          </a:prstGeom>
+          <a:noFill/>
+        </p:spPr>
+        <p:txBody>
+          <a:bodyPr wrap="none" rtlCol="0">
+            <a:spAutoFit/>
+          </a:bodyPr>
+          <a:lstStyle/>
+          <a:p>
+            <a:r>
+              <a:rPr lang="en-US" sz="2800" dirty="0"/>
+              <a:t>0</a:t>
+            </a:r>
+          </a:p>
+        </p:txBody>
+      </p:sp>
+      <p:sp>
+        <p:nvSpPr>
+          <p:cNvPr id="164" name="TextBox 163">
+            <a:extLst>
+              <a:ext uri="{FF2B5EF4-FFF2-40B4-BE49-F238E27FC236}">
+                <a16:creationId xmlns:a16="http://schemas.microsoft.com/office/drawing/2014/main" id="{DE6123A4-30F8-4230-1C38-E72DC73A43EB}"/>
+              </a:ext>
+            </a:extLst>
+          </p:cNvPr>
+          <p:cNvSpPr txBox="1"/>
+          <p:nvPr/>
+        </p:nvSpPr>
+        <p:spPr>
+          <a:xfrm>
+            <a:off x="6272644" y="4602220"/>
+            <a:ext cx="761747" cy="523220"/>
+          </a:xfrm>
+          <a:prstGeom prst="rect">
+            <a:avLst/>
+          </a:prstGeom>
+          <a:noFill/>
+        </p:spPr>
+        <p:txBody>
+          <a:bodyPr wrap="none" rtlCol="0">
+            <a:spAutoFit/>
+          </a:bodyPr>
+          <a:lstStyle/>
+          <a:p>
+            <a:r>
+              <a:rPr lang="en-US" sz="2800" dirty="0"/>
+              <a:t>729</a:t>
+            </a:r>
+          </a:p>
+        </p:txBody>
+      </p:sp>
+      <p:sp>
+        <p:nvSpPr>
+          <p:cNvPr id="165" name="TextBox 164">
+            <a:extLst>
+              <a:ext uri="{FF2B5EF4-FFF2-40B4-BE49-F238E27FC236}">
+                <a16:creationId xmlns:a16="http://schemas.microsoft.com/office/drawing/2014/main" id="{62F4DBA8-9FAD-EFD5-8A8B-BC6B67CC7766}"/>
+              </a:ext>
+            </a:extLst>
+          </p:cNvPr>
+          <p:cNvSpPr txBox="1"/>
+          <p:nvPr/>
+        </p:nvSpPr>
+        <p:spPr>
+          <a:xfrm>
+            <a:off x="6272644" y="3240075"/>
+            <a:ext cx="569387" cy="523220"/>
+          </a:xfrm>
+          <a:prstGeom prst="rect">
+            <a:avLst/>
+          </a:prstGeom>
+          <a:noFill/>
+        </p:spPr>
+        <p:txBody>
+          <a:bodyPr wrap="none" rtlCol="0">
+            <a:spAutoFit/>
+          </a:bodyPr>
+          <a:lstStyle/>
+          <a:p>
+            <a:r>
+              <a:rPr lang="en-US" sz="2800" dirty="0"/>
+              <a:t>81</a:t>
+            </a:r>
+          </a:p>
+        </p:txBody>
+      </p:sp>
+      <p:sp>
+        <p:nvSpPr>
+          <p:cNvPr id="166" name="TextBox 165">
+            <a:extLst>
+              <a:ext uri="{FF2B5EF4-FFF2-40B4-BE49-F238E27FC236}">
+                <a16:creationId xmlns:a16="http://schemas.microsoft.com/office/drawing/2014/main" id="{739175D6-50D1-EF80-4582-7ED9FDCBDB50}"/>
+              </a:ext>
+            </a:extLst>
+          </p:cNvPr>
+          <p:cNvSpPr txBox="1"/>
+          <p:nvPr/>
+        </p:nvSpPr>
+        <p:spPr>
+          <a:xfrm>
+            <a:off x="6272644" y="3921147"/>
+            <a:ext cx="954107" cy="523220"/>
+          </a:xfrm>
+          <a:prstGeom prst="rect">
+            <a:avLst/>
+          </a:prstGeom>
+          <a:noFill/>
+        </p:spPr>
+        <p:txBody>
+          <a:bodyPr wrap="none" rtlCol="0">
+            <a:spAutoFit/>
+          </a:bodyPr>
+          <a:lstStyle/>
+          <a:p>
+            <a:r>
+              <a:rPr lang="en-US" sz="2800" dirty="0"/>
+              <a:t>1024</a:t>
+            </a:r>
+          </a:p>
+        </p:txBody>
+      </p:sp>
+      <p:cxnSp>
+        <p:nvCxnSpPr>
+          <p:cNvPr id="153" name="Straight Connector 152">
+            <a:extLst>
+              <a:ext uri="{FF2B5EF4-FFF2-40B4-BE49-F238E27FC236}">
+                <a16:creationId xmlns:a16="http://schemas.microsoft.com/office/drawing/2014/main" id="{6056691C-8692-AFDA-6033-4486361CE9BA}"/>
+              </a:ext>
+            </a:extLst>
+          </p:cNvPr>
+          <p:cNvCxnSpPr/>
+          <p:nvPr/>
+        </p:nvCxnSpPr>
+        <p:spPr>
+          <a:xfrm>
+            <a:off x="6341532" y="5901490"/>
+            <a:ext cx="999082" cy="0"/>
+          </a:xfrm>
+          <a:prstGeom prst="line">
+            <a:avLst/>
+          </a:prstGeom>
+        </p:spPr>
+        <p:style>
+          <a:lnRef idx="2">
+            <a:schemeClr val="dk1"/>
+          </a:lnRef>
+          <a:fillRef idx="0">
+            <a:schemeClr val="dk1"/>
+          </a:fillRef>
+          <a:effectRef idx="1">
+            <a:schemeClr val="dk1"/>
+          </a:effectRef>
+          <a:fontRef idx="minor">
+            <a:schemeClr val="tx1"/>
+          </a:fontRef>
+        </p:style>
+      </p:cxnSp>
+      <p:sp>
+        <p:nvSpPr>
+          <p:cNvPr id="154" name="TextBox 153">
+            <a:extLst>
+              <a:ext uri="{FF2B5EF4-FFF2-40B4-BE49-F238E27FC236}">
+                <a16:creationId xmlns:a16="http://schemas.microsoft.com/office/drawing/2014/main" id="{9D946C72-E1D6-E39B-7CD4-C3376EC571C8}"/>
+              </a:ext>
+            </a:extLst>
+          </p:cNvPr>
+          <p:cNvSpPr txBox="1"/>
+          <p:nvPr/>
+        </p:nvSpPr>
+        <p:spPr>
+          <a:xfrm>
+            <a:off x="6272643" y="6059343"/>
+            <a:ext cx="954107" cy="523220"/>
+          </a:xfrm>
+          <a:prstGeom prst="rect">
+            <a:avLst/>
+          </a:prstGeom>
+          <a:noFill/>
+        </p:spPr>
+        <p:txBody>
+          <a:bodyPr wrap="none" rtlCol="0">
+            <a:spAutoFit/>
+          </a:bodyPr>
+          <a:lstStyle/>
+          <a:p>
+            <a:r>
+              <a:rPr lang="en-US" sz="2800" dirty="0"/>
+              <a:t>1834</a:t>
+            </a:r>
+          </a:p>
+        </p:txBody>
+      </p:sp>
+      <p:sp>
+        <p:nvSpPr>
+          <p:cNvPr id="155" name="TextBox 154">
+            <a:extLst>
+              <a:ext uri="{FF2B5EF4-FFF2-40B4-BE49-F238E27FC236}">
+                <a16:creationId xmlns:a16="http://schemas.microsoft.com/office/drawing/2014/main" id="{5513679A-9951-8182-C997-7FE633A4B117}"/>
+              </a:ext>
+            </a:extLst>
+          </p:cNvPr>
+          <p:cNvSpPr txBox="1"/>
+          <p:nvPr/>
+        </p:nvSpPr>
+        <p:spPr>
+          <a:xfrm>
+            <a:off x="8062184" y="5242040"/>
+            <a:ext cx="377026" cy="523220"/>
+          </a:xfrm>
+          <a:prstGeom prst="rect">
+            <a:avLst/>
+          </a:prstGeom>
+          <a:noFill/>
+        </p:spPr>
+        <p:txBody>
+          <a:bodyPr wrap="none" rtlCol="0">
+            <a:spAutoFit/>
+          </a:bodyPr>
+          <a:lstStyle/>
+          <a:p>
+            <a:r>
+              <a:rPr lang="en-US" sz="2800" b="1" dirty="0">
+                <a:solidFill>
+                  <a:schemeClr val="accent5">
+                    <a:lumMod val="75000"/>
+                  </a:schemeClr>
+                </a:solidFill>
+              </a:rPr>
+              <a:t>0</a:t>
+            </a:r>
+          </a:p>
+        </p:txBody>
+      </p:sp>
+      <p:sp>
+        <p:nvSpPr>
+          <p:cNvPr id="156" name="TextBox 155">
+            <a:extLst>
+              <a:ext uri="{FF2B5EF4-FFF2-40B4-BE49-F238E27FC236}">
+                <a16:creationId xmlns:a16="http://schemas.microsoft.com/office/drawing/2014/main" id="{DC458EB3-4CD9-4298-68CB-DD55F6C11DCD}"/>
+              </a:ext>
+            </a:extLst>
+          </p:cNvPr>
+          <p:cNvSpPr txBox="1"/>
+          <p:nvPr/>
+        </p:nvSpPr>
+        <p:spPr>
+          <a:xfrm>
+            <a:off x="8062184" y="2570176"/>
+            <a:ext cx="377026" cy="523220"/>
+          </a:xfrm>
+          <a:prstGeom prst="rect">
+            <a:avLst/>
+          </a:prstGeom>
+          <a:noFill/>
+        </p:spPr>
+        <p:txBody>
+          <a:bodyPr wrap="none" rtlCol="0">
+            <a:spAutoFit/>
+          </a:bodyPr>
+          <a:lstStyle/>
+          <a:p>
+            <a:r>
+              <a:rPr lang="en-US" sz="2800" b="1" dirty="0">
+                <a:solidFill>
+                  <a:schemeClr val="accent5">
+                    <a:lumMod val="75000"/>
+                  </a:schemeClr>
+                </a:solidFill>
+              </a:rPr>
+              <a:t>0</a:t>
+            </a:r>
+          </a:p>
+        </p:txBody>
+      </p:sp>
+      <p:sp>
+        <p:nvSpPr>
+          <p:cNvPr id="167" name="TextBox 166">
+            <a:extLst>
+              <a:ext uri="{FF2B5EF4-FFF2-40B4-BE49-F238E27FC236}">
+                <a16:creationId xmlns:a16="http://schemas.microsoft.com/office/drawing/2014/main" id="{8E297497-EC6E-D682-B979-F3F773A04836}"/>
+              </a:ext>
+            </a:extLst>
+          </p:cNvPr>
+          <p:cNvSpPr txBox="1"/>
+          <p:nvPr/>
+        </p:nvSpPr>
+        <p:spPr>
+          <a:xfrm>
+            <a:off x="8062184" y="4602220"/>
+            <a:ext cx="1061509" cy="523220"/>
+          </a:xfrm>
+          <a:prstGeom prst="rect">
+            <a:avLst/>
+          </a:prstGeom>
+          <a:noFill/>
+        </p:spPr>
+        <p:txBody>
+          <a:bodyPr wrap="none" rtlCol="0">
+            <a:spAutoFit/>
+          </a:bodyPr>
+          <a:lstStyle/>
+          <a:p>
+            <a:r>
+              <a:rPr lang="en-US" sz="2800" b="1" dirty="0">
+                <a:solidFill>
+                  <a:schemeClr val="accent5">
+                    <a:lumMod val="75000"/>
+                  </a:schemeClr>
+                </a:solidFill>
+              </a:rPr>
+              <a:t>0.397</a:t>
+            </a:r>
+          </a:p>
+        </p:txBody>
+      </p:sp>
+      <p:sp>
+        <p:nvSpPr>
+          <p:cNvPr id="168" name="TextBox 167">
+            <a:extLst>
+              <a:ext uri="{FF2B5EF4-FFF2-40B4-BE49-F238E27FC236}">
+                <a16:creationId xmlns:a16="http://schemas.microsoft.com/office/drawing/2014/main" id="{23A3D231-D81B-38FC-3A2A-52567FBD9E62}"/>
+              </a:ext>
+            </a:extLst>
+          </p:cNvPr>
+          <p:cNvSpPr txBox="1"/>
+          <p:nvPr/>
+        </p:nvSpPr>
+        <p:spPr>
+          <a:xfrm>
+            <a:off x="8062184" y="3240075"/>
+            <a:ext cx="1061509" cy="523220"/>
+          </a:xfrm>
+          <a:prstGeom prst="rect">
+            <a:avLst/>
+          </a:prstGeom>
+          <a:noFill/>
+        </p:spPr>
+        <p:txBody>
+          <a:bodyPr wrap="none" rtlCol="0">
+            <a:spAutoFit/>
+          </a:bodyPr>
+          <a:lstStyle/>
+          <a:p>
+            <a:r>
+              <a:rPr lang="en-US" sz="2800" b="1" dirty="0">
+                <a:solidFill>
+                  <a:schemeClr val="accent5">
+                    <a:lumMod val="75000"/>
+                  </a:schemeClr>
+                </a:solidFill>
+              </a:rPr>
+              <a:t>0.044</a:t>
+            </a:r>
+          </a:p>
+        </p:txBody>
+      </p:sp>
+      <p:sp>
+        <p:nvSpPr>
+          <p:cNvPr id="169" name="TextBox 168">
+            <a:extLst>
+              <a:ext uri="{FF2B5EF4-FFF2-40B4-BE49-F238E27FC236}">
+                <a16:creationId xmlns:a16="http://schemas.microsoft.com/office/drawing/2014/main" id="{0BBF0EEB-885D-5582-7291-163BBC080A4A}"/>
+              </a:ext>
+            </a:extLst>
+          </p:cNvPr>
+          <p:cNvSpPr txBox="1"/>
+          <p:nvPr/>
+        </p:nvSpPr>
+        <p:spPr>
+          <a:xfrm>
+            <a:off x="8062184" y="3921147"/>
+            <a:ext cx="1061509" cy="523220"/>
+          </a:xfrm>
+          <a:prstGeom prst="rect">
+            <a:avLst/>
+          </a:prstGeom>
+          <a:noFill/>
+        </p:spPr>
+        <p:txBody>
+          <a:bodyPr wrap="none" rtlCol="0">
+            <a:spAutoFit/>
+          </a:bodyPr>
+          <a:lstStyle/>
+          <a:p>
+            <a:r>
+              <a:rPr lang="en-US" sz="2800" b="1" dirty="0">
+                <a:solidFill>
+                  <a:schemeClr val="accent5">
+                    <a:lumMod val="75000"/>
+                  </a:schemeClr>
+                </a:solidFill>
+              </a:rPr>
+              <a:t>0.558</a:t>
+            </a:r>
+          </a:p>
+        </p:txBody>
+      </p:sp>
+      <p:sp>
+        <p:nvSpPr>
+          <p:cNvPr id="170" name="TextBox 169">
+            <a:extLst>
+              <a:ext uri="{FF2B5EF4-FFF2-40B4-BE49-F238E27FC236}">
+                <a16:creationId xmlns:a16="http://schemas.microsoft.com/office/drawing/2014/main" id="{DD6DE936-434F-EDDC-83E3-3E1244F48AC5}"/>
+              </a:ext>
+            </a:extLst>
+          </p:cNvPr>
+          <p:cNvSpPr txBox="1"/>
+          <p:nvPr/>
+        </p:nvSpPr>
+        <p:spPr>
+          <a:xfrm>
+            <a:off x="5152482" y="6059343"/>
+            <a:ext cx="997389" cy="523220"/>
+          </a:xfrm>
+          <a:prstGeom prst="rect">
+            <a:avLst/>
+          </a:prstGeom>
+          <a:noFill/>
+        </p:spPr>
+        <p:txBody>
+          <a:bodyPr wrap="none" rtlCol="0">
+            <a:spAutoFit/>
+          </a:bodyPr>
+          <a:lstStyle/>
+          <a:p>
+            <a:r>
+              <a:rPr lang="en-US" sz="2800" dirty="0"/>
+              <a:t>Sum:</a:t>
+            </a:r>
+          </a:p>
+        </p:txBody>
+      </p:sp>
+      <p:sp>
+        <p:nvSpPr>
+          <p:cNvPr id="171" name="TextBox 170">
+            <a:extLst>
+              <a:ext uri="{FF2B5EF4-FFF2-40B4-BE49-F238E27FC236}">
+                <a16:creationId xmlns:a16="http://schemas.microsoft.com/office/drawing/2014/main" id="{606D0AA6-54C1-4E56-15DE-10C3198D4CF9}"/>
+              </a:ext>
+            </a:extLst>
+          </p:cNvPr>
+          <p:cNvSpPr txBox="1"/>
+          <p:nvPr/>
+        </p:nvSpPr>
+        <p:spPr>
+          <a:xfrm>
+            <a:off x="8062184" y="2025602"/>
+            <a:ext cx="1956433" cy="523220"/>
+          </a:xfrm>
+          <a:prstGeom prst="rect">
+            <a:avLst/>
+          </a:prstGeom>
+          <a:noFill/>
+        </p:spPr>
+        <p:txBody>
+          <a:bodyPr wrap="none" rtlCol="0">
+            <a:spAutoFit/>
+          </a:bodyPr>
+          <a:lstStyle/>
+          <a:p>
+            <a:r>
+              <a:rPr lang="en-US" sz="2800" b="1" dirty="0">
+                <a:solidFill>
+                  <a:schemeClr val="accent5">
+                    <a:lumMod val="75000"/>
+                  </a:schemeClr>
+                </a:solidFill>
+              </a:rPr>
+              <a:t>Probability</a:t>
+            </a:r>
+          </a:p>
+        </p:txBody>
+      </p:sp>
+    </p:spTree>
+    <p:extLst>
+      <p:ext uri="{BB962C8B-B14F-4D97-AF65-F5344CB8AC3E}">
+        <p14:creationId xmlns:p14="http://schemas.microsoft.com/office/powerpoint/2010/main" val="1750102690"/>
       </p:ext>
     </p:extLst>
   </p:cSld>

</xml_diff>